<commit_message>
Chart the catch rate and the benchmark, and keep the current deck files
</commit_message>
<xml_diff>
--- a/docs/predictive-maintenance-executive.pptx
+++ b/docs/predictive-maintenance-executive.pptx
@@ -5,19 +5,19 @@
     <p:sldMasterId id="2147483648" r:id="rId1"/>
   </p:sldMasterIdLst>
   <p:sldIdLst>
-    <p:sldId id="256" r:id="rId7"/>
-    <p:sldId id="257" r:id="rId8"/>
-    <p:sldId id="258" r:id="rId9"/>
-    <p:sldId id="259" r:id="rId10"/>
-    <p:sldId id="260" r:id="rId11"/>
-    <p:sldId id="261" r:id="rId12"/>
-    <p:sldId id="262" r:id="rId13"/>
-    <p:sldId id="263" r:id="rId14"/>
-    <p:sldId id="264" r:id="rId15"/>
-    <p:sldId id="265" r:id="rId16"/>
-    <p:sldId id="266" r:id="rId17"/>
+    <p:sldId id="256" r:id="rId2"/>
+    <p:sldId id="257" r:id="rId3"/>
+    <p:sldId id="258" r:id="rId4"/>
+    <p:sldId id="259" r:id="rId5"/>
+    <p:sldId id="260" r:id="rId6"/>
+    <p:sldId id="261" r:id="rId7"/>
+    <p:sldId id="262" r:id="rId8"/>
+    <p:sldId id="263" r:id="rId9"/>
+    <p:sldId id="264" r:id="rId10"/>
+    <p:sldId id="265" r:id="rId11"/>
+    <p:sldId id="266" r:id="rId12"/>
   </p:sldIdLst>
-  <p:sldSz cx="12191695" cy="6858000" type="screen4x3"/>
+  <p:sldSz cx="12192000" cy="6858000"/>
   <p:notesSz cx="6858000" cy="9144000"/>
   <p:defaultTextStyle>
     <a:defPPr>
@@ -114,6 +114,22 @@
       </a:defRPr>
     </a:lvl9pPr>
   </p:defaultTextStyle>
+  <p:extLst>
+    <p:ext uri="{EFAFB233-063F-42B5-8137-9DF3F51BA10A}">
+      <p15:sldGuideLst xmlns:p15="http://schemas.microsoft.com/office/powerpoint/2012/main">
+        <p15:guide id="1" orient="horz" pos="2160">
+          <p15:clr>
+            <a:srgbClr val="A4A3A4"/>
+          </p15:clr>
+        </p15:guide>
+        <p15:guide id="2" pos="2880">
+          <p15:clr>
+            <a:srgbClr val="A4A3A4"/>
+          </p15:clr>
+        </p15:guide>
+      </p15:sldGuideLst>
+    </p:ext>
+  </p:extLst>
 </p:presentation>
 </file>
 
@@ -155,10 +171,9 @@
           <a:lstStyle/>
           <a:p>
             <a:r>
-              <a:rPr lang="en-US" smtClean="0"/>
+              <a:rPr lang="en-US"/>
               <a:t>Click to edit Master title style</a:t>
             </a:r>
-            <a:endParaRPr lang="en-US"/>
           </a:p>
         </p:txBody>
       </p:sp>
@@ -274,10 +289,9 @@
           </a:lstStyle>
           <a:p>
             <a:r>
-              <a:rPr lang="en-US" smtClean="0"/>
+              <a:rPr lang="en-US"/>
               <a:t>Click to edit Master subtitle style</a:t>
             </a:r>
-            <a:endParaRPr lang="en-US"/>
           </a:p>
         </p:txBody>
       </p:sp>
@@ -298,7 +312,7 @@
           <a:p>
             <a:fld id="{5BCAD085-E8A6-8845-BD4E-CB4CCA059FC4}" type="datetimeFigureOut">
               <a:rPr lang="en-US" smtClean="0"/>
-              <a:t>1/27/13</a:t>
+              <a:t>9/15/2026</a:t>
             </a:fld>
             <a:endParaRPr lang="en-US"/>
           </a:p>
@@ -392,10 +406,9 @@
           <a:lstStyle/>
           <a:p>
             <a:r>
-              <a:rPr lang="en-US" smtClean="0"/>
+              <a:rPr lang="en-US"/>
               <a:t>Click to edit Master title style</a:t>
             </a:r>
-            <a:endParaRPr lang="en-US"/>
           </a:p>
         </p:txBody>
       </p:sp>
@@ -416,38 +429,37 @@
           <a:p>
             <a:pPr lvl="0"/>
             <a:r>
-              <a:rPr lang="en-US" smtClean="0"/>
+              <a:rPr lang="en-US"/>
               <a:t>Click to edit Master text styles</a:t>
             </a:r>
           </a:p>
           <a:p>
             <a:pPr lvl="1"/>
             <a:r>
-              <a:rPr lang="en-US" smtClean="0"/>
+              <a:rPr lang="en-US"/>
               <a:t>Second level</a:t>
             </a:r>
           </a:p>
           <a:p>
             <a:pPr lvl="2"/>
             <a:r>
-              <a:rPr lang="en-US" smtClean="0"/>
+              <a:rPr lang="en-US"/>
               <a:t>Third level</a:t>
             </a:r>
           </a:p>
           <a:p>
             <a:pPr lvl="3"/>
             <a:r>
-              <a:rPr lang="en-US" smtClean="0"/>
+              <a:rPr lang="en-US"/>
               <a:t>Fourth level</a:t>
             </a:r>
           </a:p>
           <a:p>
             <a:pPr lvl="4"/>
             <a:r>
-              <a:rPr lang="en-US" smtClean="0"/>
+              <a:rPr lang="en-US"/>
               <a:t>Fifth level</a:t>
             </a:r>
-            <a:endParaRPr lang="en-US"/>
           </a:p>
         </p:txBody>
       </p:sp>
@@ -468,7 +480,7 @@
           <a:p>
             <a:fld id="{5BCAD085-E8A6-8845-BD4E-CB4CCA059FC4}" type="datetimeFigureOut">
               <a:rPr lang="en-US" smtClean="0"/>
-              <a:t>1/27/13</a:t>
+              <a:t>9/15/2026</a:t>
             </a:fld>
             <a:endParaRPr lang="en-US"/>
           </a:p>
@@ -567,10 +579,9 @@
           <a:lstStyle/>
           <a:p>
             <a:r>
-              <a:rPr lang="en-US" smtClean="0"/>
+              <a:rPr lang="en-US"/>
               <a:t>Click to edit Master title style</a:t>
             </a:r>
-            <a:endParaRPr lang="en-US"/>
           </a:p>
         </p:txBody>
       </p:sp>
@@ -596,38 +607,37 @@
           <a:p>
             <a:pPr lvl="0"/>
             <a:r>
-              <a:rPr lang="en-US" smtClean="0"/>
+              <a:rPr lang="en-US"/>
               <a:t>Click to edit Master text styles</a:t>
             </a:r>
           </a:p>
           <a:p>
             <a:pPr lvl="1"/>
             <a:r>
-              <a:rPr lang="en-US" smtClean="0"/>
+              <a:rPr lang="en-US"/>
               <a:t>Second level</a:t>
             </a:r>
           </a:p>
           <a:p>
             <a:pPr lvl="2"/>
             <a:r>
-              <a:rPr lang="en-US" smtClean="0"/>
+              <a:rPr lang="en-US"/>
               <a:t>Third level</a:t>
             </a:r>
           </a:p>
           <a:p>
             <a:pPr lvl="3"/>
             <a:r>
-              <a:rPr lang="en-US" smtClean="0"/>
+              <a:rPr lang="en-US"/>
               <a:t>Fourth level</a:t>
             </a:r>
           </a:p>
           <a:p>
             <a:pPr lvl="4"/>
             <a:r>
-              <a:rPr lang="en-US" smtClean="0"/>
+              <a:rPr lang="en-US"/>
               <a:t>Fifth level</a:t>
             </a:r>
-            <a:endParaRPr lang="en-US"/>
           </a:p>
         </p:txBody>
       </p:sp>
@@ -648,7 +658,7 @@
           <a:p>
             <a:fld id="{5BCAD085-E8A6-8845-BD4E-CB4CCA059FC4}" type="datetimeFigureOut">
               <a:rPr lang="en-US" smtClean="0"/>
-              <a:t>1/27/13</a:t>
+              <a:t>9/15/2026</a:t>
             </a:fld>
             <a:endParaRPr lang="en-US"/>
           </a:p>
@@ -742,10 +752,9 @@
           <a:lstStyle/>
           <a:p>
             <a:r>
-              <a:rPr lang="en-US" smtClean="0"/>
+              <a:rPr lang="en-US"/>
               <a:t>Click to edit Master title style</a:t>
             </a:r>
-            <a:endParaRPr lang="en-US"/>
           </a:p>
         </p:txBody>
       </p:sp>
@@ -766,38 +775,37 @@
           <a:p>
             <a:pPr lvl="0"/>
             <a:r>
-              <a:rPr lang="en-US" smtClean="0"/>
+              <a:rPr lang="en-US"/>
               <a:t>Click to edit Master text styles</a:t>
             </a:r>
           </a:p>
           <a:p>
             <a:pPr lvl="1"/>
             <a:r>
-              <a:rPr lang="en-US" smtClean="0"/>
+              <a:rPr lang="en-US"/>
               <a:t>Second level</a:t>
             </a:r>
           </a:p>
           <a:p>
             <a:pPr lvl="2"/>
             <a:r>
-              <a:rPr lang="en-US" smtClean="0"/>
+              <a:rPr lang="en-US"/>
               <a:t>Third level</a:t>
             </a:r>
           </a:p>
           <a:p>
             <a:pPr lvl="3"/>
             <a:r>
-              <a:rPr lang="en-US" smtClean="0"/>
+              <a:rPr lang="en-US"/>
               <a:t>Fourth level</a:t>
             </a:r>
           </a:p>
           <a:p>
             <a:pPr lvl="4"/>
             <a:r>
-              <a:rPr lang="en-US" smtClean="0"/>
+              <a:rPr lang="en-US"/>
               <a:t>Fifth level</a:t>
             </a:r>
-            <a:endParaRPr lang="en-US"/>
           </a:p>
         </p:txBody>
       </p:sp>
@@ -818,7 +826,7 @@
           <a:p>
             <a:fld id="{5BCAD085-E8A6-8845-BD4E-CB4CCA059FC4}" type="datetimeFigureOut">
               <a:rPr lang="en-US" smtClean="0"/>
-              <a:t>1/27/13</a:t>
+              <a:t>9/15/2026</a:t>
             </a:fld>
             <a:endParaRPr lang="en-US"/>
           </a:p>
@@ -921,10 +929,9 @@
           </a:lstStyle>
           <a:p>
             <a:r>
-              <a:rPr lang="en-US" smtClean="0"/>
+              <a:rPr lang="en-US"/>
               <a:t>Click to edit Master title style</a:t>
             </a:r>
-            <a:endParaRPr lang="en-US"/>
           </a:p>
         </p:txBody>
       </p:sp>
@@ -1041,7 +1048,7 @@
           <a:p>
             <a:pPr lvl="0"/>
             <a:r>
-              <a:rPr lang="en-US" smtClean="0"/>
+              <a:rPr lang="en-US"/>
               <a:t>Click to edit Master text styles</a:t>
             </a:r>
           </a:p>
@@ -1064,7 +1071,7 @@
           <a:p>
             <a:fld id="{5BCAD085-E8A6-8845-BD4E-CB4CCA059FC4}" type="datetimeFigureOut">
               <a:rPr lang="en-US" smtClean="0"/>
-              <a:t>1/27/13</a:t>
+              <a:t>9/15/2026</a:t>
             </a:fld>
             <a:endParaRPr lang="en-US"/>
           </a:p>
@@ -1158,10 +1165,9 @@
           <a:lstStyle/>
           <a:p>
             <a:r>
-              <a:rPr lang="en-US" smtClean="0"/>
+              <a:rPr lang="en-US"/>
               <a:t>Click to edit Master title style</a:t>
             </a:r>
-            <a:endParaRPr lang="en-US"/>
           </a:p>
         </p:txBody>
       </p:sp>
@@ -1215,38 +1221,37 @@
           <a:p>
             <a:pPr lvl="0"/>
             <a:r>
-              <a:rPr lang="en-US" smtClean="0"/>
+              <a:rPr lang="en-US"/>
               <a:t>Click to edit Master text styles</a:t>
             </a:r>
           </a:p>
           <a:p>
             <a:pPr lvl="1"/>
             <a:r>
-              <a:rPr lang="en-US" smtClean="0"/>
+              <a:rPr lang="en-US"/>
               <a:t>Second level</a:t>
             </a:r>
           </a:p>
           <a:p>
             <a:pPr lvl="2"/>
             <a:r>
-              <a:rPr lang="en-US" smtClean="0"/>
+              <a:rPr lang="en-US"/>
               <a:t>Third level</a:t>
             </a:r>
           </a:p>
           <a:p>
             <a:pPr lvl="3"/>
             <a:r>
-              <a:rPr lang="en-US" smtClean="0"/>
+              <a:rPr lang="en-US"/>
               <a:t>Fourth level</a:t>
             </a:r>
           </a:p>
           <a:p>
             <a:pPr lvl="4"/>
             <a:r>
-              <a:rPr lang="en-US" smtClean="0"/>
+              <a:rPr lang="en-US"/>
               <a:t>Fifth level</a:t>
             </a:r>
-            <a:endParaRPr lang="en-US"/>
           </a:p>
         </p:txBody>
       </p:sp>
@@ -1300,38 +1305,37 @@
           <a:p>
             <a:pPr lvl="0"/>
             <a:r>
-              <a:rPr lang="en-US" smtClean="0"/>
+              <a:rPr lang="en-US"/>
               <a:t>Click to edit Master text styles</a:t>
             </a:r>
           </a:p>
           <a:p>
             <a:pPr lvl="1"/>
             <a:r>
-              <a:rPr lang="en-US" smtClean="0"/>
+              <a:rPr lang="en-US"/>
               <a:t>Second level</a:t>
             </a:r>
           </a:p>
           <a:p>
             <a:pPr lvl="2"/>
             <a:r>
-              <a:rPr lang="en-US" smtClean="0"/>
+              <a:rPr lang="en-US"/>
               <a:t>Third level</a:t>
             </a:r>
           </a:p>
           <a:p>
             <a:pPr lvl="3"/>
             <a:r>
-              <a:rPr lang="en-US" smtClean="0"/>
+              <a:rPr lang="en-US"/>
               <a:t>Fourth level</a:t>
             </a:r>
           </a:p>
           <a:p>
             <a:pPr lvl="4"/>
             <a:r>
-              <a:rPr lang="en-US" smtClean="0"/>
+              <a:rPr lang="en-US"/>
               <a:t>Fifth level</a:t>
             </a:r>
-            <a:endParaRPr lang="en-US"/>
           </a:p>
         </p:txBody>
       </p:sp>
@@ -1352,7 +1356,7 @@
           <a:p>
             <a:fld id="{5BCAD085-E8A6-8845-BD4E-CB4CCA059FC4}" type="datetimeFigureOut">
               <a:rPr lang="en-US" smtClean="0"/>
-              <a:t>1/27/13</a:t>
+              <a:t>9/15/2026</a:t>
             </a:fld>
             <a:endParaRPr lang="en-US"/>
           </a:p>
@@ -1450,10 +1454,9 @@
           </a:lstStyle>
           <a:p>
             <a:r>
-              <a:rPr lang="en-US" smtClean="0"/>
+              <a:rPr lang="en-US"/>
               <a:t>Click to edit Master title style</a:t>
             </a:r>
-            <a:endParaRPr lang="en-US"/>
           </a:p>
         </p:txBody>
       </p:sp>
@@ -1516,7 +1519,7 @@
           <a:p>
             <a:pPr lvl="0"/>
             <a:r>
-              <a:rPr lang="en-US" smtClean="0"/>
+              <a:rPr lang="en-US"/>
               <a:t>Click to edit Master text styles</a:t>
             </a:r>
           </a:p>
@@ -1572,38 +1575,37 @@
           <a:p>
             <a:pPr lvl="0"/>
             <a:r>
-              <a:rPr lang="en-US" smtClean="0"/>
+              <a:rPr lang="en-US"/>
               <a:t>Click to edit Master text styles</a:t>
             </a:r>
           </a:p>
           <a:p>
             <a:pPr lvl="1"/>
             <a:r>
-              <a:rPr lang="en-US" smtClean="0"/>
+              <a:rPr lang="en-US"/>
               <a:t>Second level</a:t>
             </a:r>
           </a:p>
           <a:p>
             <a:pPr lvl="2"/>
             <a:r>
-              <a:rPr lang="en-US" smtClean="0"/>
+              <a:rPr lang="en-US"/>
               <a:t>Third level</a:t>
             </a:r>
           </a:p>
           <a:p>
             <a:pPr lvl="3"/>
             <a:r>
-              <a:rPr lang="en-US" smtClean="0"/>
+              <a:rPr lang="en-US"/>
               <a:t>Fourth level</a:t>
             </a:r>
           </a:p>
           <a:p>
             <a:pPr lvl="4"/>
             <a:r>
-              <a:rPr lang="en-US" smtClean="0"/>
+              <a:rPr lang="en-US"/>
               <a:t>Fifth level</a:t>
             </a:r>
-            <a:endParaRPr lang="en-US"/>
           </a:p>
         </p:txBody>
       </p:sp>
@@ -1666,7 +1668,7 @@
           <a:p>
             <a:pPr lvl="0"/>
             <a:r>
-              <a:rPr lang="en-US" smtClean="0"/>
+              <a:rPr lang="en-US"/>
               <a:t>Click to edit Master text styles</a:t>
             </a:r>
           </a:p>
@@ -1722,38 +1724,37 @@
           <a:p>
             <a:pPr lvl="0"/>
             <a:r>
-              <a:rPr lang="en-US" smtClean="0"/>
+              <a:rPr lang="en-US"/>
               <a:t>Click to edit Master text styles</a:t>
             </a:r>
           </a:p>
           <a:p>
             <a:pPr lvl="1"/>
             <a:r>
-              <a:rPr lang="en-US" smtClean="0"/>
+              <a:rPr lang="en-US"/>
               <a:t>Second level</a:t>
             </a:r>
           </a:p>
           <a:p>
             <a:pPr lvl="2"/>
             <a:r>
-              <a:rPr lang="en-US" smtClean="0"/>
+              <a:rPr lang="en-US"/>
               <a:t>Third level</a:t>
             </a:r>
           </a:p>
           <a:p>
             <a:pPr lvl="3"/>
             <a:r>
-              <a:rPr lang="en-US" smtClean="0"/>
+              <a:rPr lang="en-US"/>
               <a:t>Fourth level</a:t>
             </a:r>
           </a:p>
           <a:p>
             <a:pPr lvl="4"/>
             <a:r>
-              <a:rPr lang="en-US" smtClean="0"/>
+              <a:rPr lang="en-US"/>
               <a:t>Fifth level</a:t>
             </a:r>
-            <a:endParaRPr lang="en-US"/>
           </a:p>
         </p:txBody>
       </p:sp>
@@ -1774,7 +1775,7 @@
           <a:p>
             <a:fld id="{5BCAD085-E8A6-8845-BD4E-CB4CCA059FC4}" type="datetimeFigureOut">
               <a:rPr lang="en-US" smtClean="0"/>
-              <a:t>1/27/13</a:t>
+              <a:t>9/15/2026</a:t>
             </a:fld>
             <a:endParaRPr lang="en-US"/>
           </a:p>
@@ -1868,10 +1869,9 @@
           <a:lstStyle/>
           <a:p>
             <a:r>
-              <a:rPr lang="en-US" smtClean="0"/>
+              <a:rPr lang="en-US"/>
               <a:t>Click to edit Master title style</a:t>
             </a:r>
-            <a:endParaRPr lang="en-US"/>
           </a:p>
         </p:txBody>
       </p:sp>
@@ -1892,7 +1892,7 @@
           <a:p>
             <a:fld id="{5BCAD085-E8A6-8845-BD4E-CB4CCA059FC4}" type="datetimeFigureOut">
               <a:rPr lang="en-US" smtClean="0"/>
-              <a:t>1/27/13</a:t>
+              <a:t>9/15/2026</a:t>
             </a:fld>
             <a:endParaRPr lang="en-US"/>
           </a:p>
@@ -1987,7 +1987,7 @@
           <a:p>
             <a:fld id="{5BCAD085-E8A6-8845-BD4E-CB4CCA059FC4}" type="datetimeFigureOut">
               <a:rPr lang="en-US" smtClean="0"/>
-              <a:t>1/27/13</a:t>
+              <a:t>9/15/2026</a:t>
             </a:fld>
             <a:endParaRPr lang="en-US"/>
           </a:p>
@@ -2090,10 +2090,9 @@
           </a:lstStyle>
           <a:p>
             <a:r>
-              <a:rPr lang="en-US" smtClean="0"/>
+              <a:rPr lang="en-US"/>
               <a:t>Click to edit Master title style</a:t>
             </a:r>
-            <a:endParaRPr lang="en-US"/>
           </a:p>
         </p:txBody>
       </p:sp>
@@ -2147,38 +2146,37 @@
           <a:p>
             <a:pPr lvl="0"/>
             <a:r>
-              <a:rPr lang="en-US" smtClean="0"/>
+              <a:rPr lang="en-US"/>
               <a:t>Click to edit Master text styles</a:t>
             </a:r>
           </a:p>
           <a:p>
             <a:pPr lvl="1"/>
             <a:r>
-              <a:rPr lang="en-US" smtClean="0"/>
+              <a:rPr lang="en-US"/>
               <a:t>Second level</a:t>
             </a:r>
           </a:p>
           <a:p>
             <a:pPr lvl="2"/>
             <a:r>
-              <a:rPr lang="en-US" smtClean="0"/>
+              <a:rPr lang="en-US"/>
               <a:t>Third level</a:t>
             </a:r>
           </a:p>
           <a:p>
             <a:pPr lvl="3"/>
             <a:r>
-              <a:rPr lang="en-US" smtClean="0"/>
+              <a:rPr lang="en-US"/>
               <a:t>Fourth level</a:t>
             </a:r>
           </a:p>
           <a:p>
             <a:pPr lvl="4"/>
             <a:r>
-              <a:rPr lang="en-US" smtClean="0"/>
+              <a:rPr lang="en-US"/>
               <a:t>Fifth level</a:t>
             </a:r>
-            <a:endParaRPr lang="en-US"/>
           </a:p>
         </p:txBody>
       </p:sp>
@@ -2241,7 +2239,7 @@
           <a:p>
             <a:pPr lvl="0"/>
             <a:r>
-              <a:rPr lang="en-US" smtClean="0"/>
+              <a:rPr lang="en-US"/>
               <a:t>Click to edit Master text styles</a:t>
             </a:r>
           </a:p>
@@ -2264,7 +2262,7 @@
           <a:p>
             <a:fld id="{5BCAD085-E8A6-8845-BD4E-CB4CCA059FC4}" type="datetimeFigureOut">
               <a:rPr lang="en-US" smtClean="0"/>
-              <a:t>1/27/13</a:t>
+              <a:t>9/15/2026</a:t>
             </a:fld>
             <a:endParaRPr lang="en-US"/>
           </a:p>
@@ -2367,10 +2365,9 @@
           </a:lstStyle>
           <a:p>
             <a:r>
-              <a:rPr lang="en-US" smtClean="0"/>
+              <a:rPr lang="en-US"/>
               <a:t>Click to edit Master title style</a:t>
             </a:r>
-            <a:endParaRPr lang="en-US"/>
           </a:p>
         </p:txBody>
       </p:sp>
@@ -2494,7 +2491,7 @@
           <a:p>
             <a:pPr lvl="0"/>
             <a:r>
-              <a:rPr lang="en-US" smtClean="0"/>
+              <a:rPr lang="en-US"/>
               <a:t>Click to edit Master text styles</a:t>
             </a:r>
           </a:p>
@@ -2517,7 +2514,7 @@
           <a:p>
             <a:fld id="{5BCAD085-E8A6-8845-BD4E-CB4CCA059FC4}" type="datetimeFigureOut">
               <a:rPr lang="en-US" smtClean="0"/>
-              <a:t>1/27/13</a:t>
+              <a:t>9/15/2026</a:t>
             </a:fld>
             <a:endParaRPr lang="en-US"/>
           </a:p>
@@ -2626,10 +2623,9 @@
           <a:lstStyle/>
           <a:p>
             <a:r>
-              <a:rPr lang="en-US" smtClean="0"/>
+              <a:rPr lang="en-US"/>
               <a:t>Click to edit Master title style</a:t>
             </a:r>
-            <a:endParaRPr lang="en-US"/>
           </a:p>
         </p:txBody>
       </p:sp>
@@ -2660,38 +2656,37 @@
           <a:p>
             <a:pPr lvl="0"/>
             <a:r>
-              <a:rPr lang="en-US" smtClean="0"/>
+              <a:rPr lang="en-US"/>
               <a:t>Click to edit Master text styles</a:t>
             </a:r>
           </a:p>
           <a:p>
             <a:pPr lvl="1"/>
             <a:r>
-              <a:rPr lang="en-US" smtClean="0"/>
+              <a:rPr lang="en-US"/>
               <a:t>Second level</a:t>
             </a:r>
           </a:p>
           <a:p>
             <a:pPr lvl="2"/>
             <a:r>
-              <a:rPr lang="en-US" smtClean="0"/>
+              <a:rPr lang="en-US"/>
               <a:t>Third level</a:t>
             </a:r>
           </a:p>
           <a:p>
             <a:pPr lvl="3"/>
             <a:r>
-              <a:rPr lang="en-US" smtClean="0"/>
+              <a:rPr lang="en-US"/>
               <a:t>Fourth level</a:t>
             </a:r>
           </a:p>
           <a:p>
             <a:pPr lvl="4"/>
             <a:r>
-              <a:rPr lang="en-US" smtClean="0"/>
+              <a:rPr lang="en-US"/>
               <a:t>Fifth level</a:t>
             </a:r>
-            <a:endParaRPr lang="en-US"/>
           </a:p>
         </p:txBody>
       </p:sp>
@@ -2730,7 +2725,7 @@
           <a:p>
             <a:fld id="{5BCAD085-E8A6-8845-BD4E-CB4CCA059FC4}" type="datetimeFigureOut">
               <a:rPr lang="en-US" smtClean="0"/>
-              <a:t>1/27/13</a:t>
+              <a:t>9/15/2026</a:t>
             </a:fld>
             <a:endParaRPr lang="en-US"/>
           </a:p>
@@ -3089,7 +3084,7 @@
 </file>
 
 <file path=ppt/slides/slide1.xml><?xml version="1.0" encoding="utf-8"?>
-<p:sld xmlns:a="http://schemas.openxmlformats.org/drawingml/2006/main" xmlns:p="http://schemas.openxmlformats.org/presentationml/2006/main" xmlns:r="http://schemas.openxmlformats.org/officeDocument/2006/relationships">
+<p:sld xmlns:a="http://schemas.openxmlformats.org/drawingml/2006/main" xmlns:r="http://schemas.openxmlformats.org/officeDocument/2006/relationships" xmlns:p="http://schemas.openxmlformats.org/presentationml/2006/main">
   <p:cSld>
     <p:spTree>
       <p:nvGrpSpPr>
@@ -3097,7 +3092,14 @@
         <p:cNvGrpSpPr/>
         <p:nvPr/>
       </p:nvGrpSpPr>
-      <p:grpSpPr/>
+      <p:grpSpPr>
+        <a:xfrm>
+          <a:off x="0" y="0"/>
+          <a:ext cx="0" cy="0"/>
+          <a:chOff x="0" y="0"/>
+          <a:chExt cx="0" cy="0"/>
+        </a:xfrm>
+      </p:grpSpPr>
       <p:sp>
         <p:nvSpPr>
           <p:cNvPr id="2" name="Rectangle 1"/>
@@ -3139,6 +3141,7 @@
           <a:lstStyle/>
           <a:p>
             <a:pPr algn="ctr"/>
+            <a:endParaRPr/>
           </a:p>
         </p:txBody>
       </p:sp>
@@ -3151,7 +3154,7 @@
         <p:spPr>
           <a:xfrm>
             <a:off x="1005840" y="2103120"/>
-            <a:ext cx="9692640" cy="2743200"/>
+            <a:ext cx="9692640" cy="2239331"/>
           </a:xfrm>
           <a:prstGeom prst="rect">
             <a:avLst/>
@@ -3159,7 +3162,7 @@
           <a:noFill/>
         </p:spPr>
         <p:txBody>
-          <a:bodyPr wrap="square" lIns="0" rIns="0" tIns="0" bIns="0">
+          <a:bodyPr wrap="square" lIns="0" tIns="0" rIns="0" bIns="0">
             <a:spAutoFit/>
           </a:bodyPr>
           <a:lstStyle/>
@@ -3173,7 +3176,7 @@
               </a:spcAft>
             </a:pPr>
             <a:r>
-              <a:rPr sz="1300" b="1">
+              <a:rPr sz="1300" b="1" dirty="0">
                 <a:solidFill>
                   <a:srgbClr val="1F7A6B"/>
                 </a:solidFill>
@@ -3192,7 +3195,7 @@
               </a:spcAft>
             </a:pPr>
             <a:r>
-              <a:rPr sz="4000" b="1">
+              <a:rPr sz="4000" b="1" dirty="0">
                 <a:solidFill>
                   <a:srgbClr val="0B2545"/>
                 </a:solidFill>
@@ -3211,7 +3214,7 @@
               </a:spcAft>
             </a:pPr>
             <a:r>
-              <a:rPr sz="4000" b="1">
+              <a:rPr sz="4000" b="1" dirty="0">
                 <a:solidFill>
                   <a:srgbClr val="0B2545"/>
                 </a:solidFill>
@@ -3230,13 +3233,31 @@
               </a:spcAft>
             </a:pPr>
             <a:r>
-              <a:rPr sz="1600" b="0">
+              <a:rPr sz="1600" b="0" dirty="0">
                 <a:solidFill>
                   <a:srgbClr val="343D4A"/>
                 </a:solidFill>
                 <a:latin typeface="Calibri"/>
               </a:rPr>
-              <a:t>A cost-optimal failure-risk model on the SCANIA Component X fleet, and what it would take to run it.</a:t>
+              <a:t>A cost-optimal failure-risk model on the SCANIA Component X fleet</a:t>
+            </a:r>
+            <a:r>
+              <a:rPr lang="en-US" sz="1600" dirty="0">
+                <a:solidFill>
+                  <a:srgbClr val="343D4A"/>
+                </a:solidFill>
+                <a:latin typeface="Calibri"/>
+              </a:rPr>
+              <a:t> </a:t>
+            </a:r>
+            <a:r>
+              <a:rPr sz="1600" b="0" dirty="0">
+                <a:solidFill>
+                  <a:srgbClr val="343D4A"/>
+                </a:solidFill>
+                <a:latin typeface="Calibri"/>
+              </a:rPr>
+              <a:t>and what it would take to run it.</a:t>
             </a:r>
           </a:p>
         </p:txBody>
@@ -3282,6 +3303,7 @@
           <a:lstStyle/>
           <a:p>
             <a:pPr algn="ctr"/>
+            <a:endParaRPr/>
           </a:p>
         </p:txBody>
       </p:sp>
@@ -3302,7 +3324,7 @@
           <a:noFill/>
         </p:spPr>
         <p:txBody>
-          <a:bodyPr wrap="square" lIns="0" rIns="0" tIns="0" bIns="0">
+          <a:bodyPr wrap="square" lIns="0" tIns="0" rIns="0" bIns="0">
             <a:spAutoFit/>
           </a:bodyPr>
           <a:lstStyle/>
@@ -3316,7 +3338,7 @@
               </a:spcAft>
             </a:pPr>
             <a:r>
-              <a:rPr sz="1300" b="0">
+              <a:rPr sz="1300" b="0" dirty="0">
                 <a:solidFill>
                   <a:srgbClr val="8A94A0"/>
                 </a:solidFill>
@@ -3335,7 +3357,7 @@
               </a:spcAft>
             </a:pPr>
             <a:r>
-              <a:rPr sz="1300" b="0">
+              <a:rPr sz="1300" b="0" dirty="0">
                 <a:solidFill>
                   <a:srgbClr val="8A94A0"/>
                 </a:solidFill>
@@ -3355,7 +3377,7 @@
 </file>
 
 <file path=ppt/slides/slide10.xml><?xml version="1.0" encoding="utf-8"?>
-<p:sld xmlns:a="http://schemas.openxmlformats.org/drawingml/2006/main" xmlns:p="http://schemas.openxmlformats.org/presentationml/2006/main" xmlns:r="http://schemas.openxmlformats.org/officeDocument/2006/relationships">
+<p:sld xmlns:a="http://schemas.openxmlformats.org/drawingml/2006/main" xmlns:r="http://schemas.openxmlformats.org/officeDocument/2006/relationships" xmlns:p="http://schemas.openxmlformats.org/presentationml/2006/main">
   <p:cSld>
     <p:spTree>
       <p:nvGrpSpPr>
@@ -3363,7 +3385,14 @@
         <p:cNvGrpSpPr/>
         <p:nvPr/>
       </p:nvGrpSpPr>
-      <p:grpSpPr/>
+      <p:grpSpPr>
+        <a:xfrm>
+          <a:off x="0" y="0"/>
+          <a:ext cx="0" cy="0"/>
+          <a:chOff x="0" y="0"/>
+          <a:chExt cx="0" cy="0"/>
+        </a:xfrm>
+      </p:grpSpPr>
       <p:sp>
         <p:nvSpPr>
           <p:cNvPr id="2" name="TextBox 1"/>
@@ -3381,7 +3410,7 @@
           <a:noFill/>
         </p:spPr>
         <p:txBody>
-          <a:bodyPr wrap="square" lIns="0" rIns="0" tIns="0" bIns="0">
+          <a:bodyPr wrap="square" lIns="0" tIns="0" rIns="0" bIns="0">
             <a:spAutoFit/>
           </a:bodyPr>
           <a:lstStyle/>
@@ -3466,6 +3495,7 @@
           <a:lstStyle/>
           <a:p>
             <a:pPr algn="ctr"/>
+            <a:endParaRPr/>
           </a:p>
         </p:txBody>
       </p:sp>
@@ -3486,7 +3516,7 @@
           <a:noFill/>
         </p:spPr>
         <p:txBody>
-          <a:bodyPr wrap="square" lIns="0" rIns="0" tIns="0" bIns="0">
+          <a:bodyPr wrap="square" lIns="0" tIns="0" rIns="0" bIns="0">
             <a:spAutoFit/>
           </a:bodyPr>
           <a:lstStyle/>
@@ -3528,7 +3558,7 @@
           <a:noFill/>
         </p:spPr>
         <p:txBody>
-          <a:bodyPr wrap="square" lIns="0" rIns="0" tIns="0" bIns="0">
+          <a:bodyPr wrap="square" lIns="0" tIns="0" rIns="0" bIns="0">
             <a:spAutoFit/>
           </a:bodyPr>
           <a:lstStyle/>
@@ -3655,7 +3685,7 @@
 </file>
 
 <file path=ppt/slides/slide11.xml><?xml version="1.0" encoding="utf-8"?>
-<p:sld xmlns:a="http://schemas.openxmlformats.org/drawingml/2006/main" xmlns:p="http://schemas.openxmlformats.org/presentationml/2006/main" xmlns:r="http://schemas.openxmlformats.org/officeDocument/2006/relationships">
+<p:sld xmlns:a="http://schemas.openxmlformats.org/drawingml/2006/main" xmlns:r="http://schemas.openxmlformats.org/officeDocument/2006/relationships" xmlns:p="http://schemas.openxmlformats.org/presentationml/2006/main">
   <p:cSld>
     <p:spTree>
       <p:nvGrpSpPr>
@@ -3663,7 +3693,14 @@
         <p:cNvGrpSpPr/>
         <p:nvPr/>
       </p:nvGrpSpPr>
-      <p:grpSpPr/>
+      <p:grpSpPr>
+        <a:xfrm>
+          <a:off x="0" y="0"/>
+          <a:ext cx="0" cy="0"/>
+          <a:chOff x="0" y="0"/>
+          <a:chExt cx="0" cy="0"/>
+        </a:xfrm>
+      </p:grpSpPr>
       <p:sp>
         <p:nvSpPr>
           <p:cNvPr id="2" name="TextBox 1"/>
@@ -3681,7 +3718,7 @@
           <a:noFill/>
         </p:spPr>
         <p:txBody>
-          <a:bodyPr wrap="square" lIns="0" rIns="0" tIns="0" bIns="0">
+          <a:bodyPr wrap="square" lIns="0" tIns="0" rIns="0" bIns="0">
             <a:spAutoFit/>
           </a:bodyPr>
           <a:lstStyle/>
@@ -3766,6 +3803,7 @@
           <a:lstStyle/>
           <a:p>
             <a:pPr algn="ctr"/>
+            <a:endParaRPr/>
           </a:p>
         </p:txBody>
       </p:sp>
@@ -3786,7 +3824,7 @@
           <a:noFill/>
         </p:spPr>
         <p:txBody>
-          <a:bodyPr wrap="square" lIns="0" rIns="0" tIns="0" bIns="0">
+          <a:bodyPr wrap="square" lIns="0" tIns="0" rIns="0" bIns="0">
             <a:spAutoFit/>
           </a:bodyPr>
           <a:lstStyle/>
@@ -3854,6 +3892,7 @@
           <a:lstStyle/>
           <a:p>
             <a:pPr algn="ctr"/>
+            <a:endParaRPr/>
           </a:p>
         </p:txBody>
       </p:sp>
@@ -3874,7 +3913,7 @@
           <a:noFill/>
         </p:spPr>
         <p:txBody>
-          <a:bodyPr wrap="square" lIns="0" rIns="0" tIns="0" bIns="0">
+          <a:bodyPr wrap="square" lIns="0" tIns="0" rIns="0" bIns="0">
             <a:spAutoFit/>
           </a:bodyPr>
           <a:lstStyle/>
@@ -3962,6 +4001,7 @@
           <a:lstStyle/>
           <a:p>
             <a:pPr algn="ctr"/>
+            <a:endParaRPr/>
           </a:p>
         </p:txBody>
       </p:sp>
@@ -3982,7 +4022,7 @@
           <a:noFill/>
         </p:spPr>
         <p:txBody>
-          <a:bodyPr wrap="square" lIns="0" rIns="0" tIns="0" bIns="0">
+          <a:bodyPr wrap="square" lIns="0" tIns="0" rIns="0" bIns="0">
             <a:spAutoFit/>
           </a:bodyPr>
           <a:lstStyle/>
@@ -4070,6 +4110,7 @@
           <a:lstStyle/>
           <a:p>
             <a:pPr algn="ctr"/>
+            <a:endParaRPr/>
           </a:p>
         </p:txBody>
       </p:sp>
@@ -4090,7 +4131,7 @@
           <a:noFill/>
         </p:spPr>
         <p:txBody>
-          <a:bodyPr wrap="square" lIns="0" rIns="0" tIns="0" bIns="0">
+          <a:bodyPr wrap="square" lIns="0" tIns="0" rIns="0" bIns="0">
             <a:spAutoFit/>
           </a:bodyPr>
           <a:lstStyle/>
@@ -4178,6 +4219,7 @@
           <a:lstStyle/>
           <a:p>
             <a:pPr algn="ctr"/>
+            <a:endParaRPr/>
           </a:p>
         </p:txBody>
       </p:sp>
@@ -4198,7 +4240,7 @@
           <a:noFill/>
         </p:spPr>
         <p:txBody>
-          <a:bodyPr wrap="square" lIns="0" rIns="0" tIns="0" bIns="0">
+          <a:bodyPr wrap="square" lIns="0" tIns="0" rIns="0" bIns="0">
             <a:spAutoFit/>
           </a:bodyPr>
           <a:lstStyle/>
@@ -4252,7 +4294,7 @@
 </file>
 
 <file path=ppt/slides/slide2.xml><?xml version="1.0" encoding="utf-8"?>
-<p:sld xmlns:a="http://schemas.openxmlformats.org/drawingml/2006/main" xmlns:p="http://schemas.openxmlformats.org/presentationml/2006/main" xmlns:r="http://schemas.openxmlformats.org/officeDocument/2006/relationships">
+<p:sld xmlns:a="http://schemas.openxmlformats.org/drawingml/2006/main" xmlns:r="http://schemas.openxmlformats.org/officeDocument/2006/relationships" xmlns:p="http://schemas.openxmlformats.org/presentationml/2006/main">
   <p:cSld>
     <p:spTree>
       <p:nvGrpSpPr>
@@ -4260,7 +4302,14 @@
         <p:cNvGrpSpPr/>
         <p:nvPr/>
       </p:nvGrpSpPr>
-      <p:grpSpPr/>
+      <p:grpSpPr>
+        <a:xfrm>
+          <a:off x="0" y="0"/>
+          <a:ext cx="0" cy="0"/>
+          <a:chOff x="0" y="0"/>
+          <a:chExt cx="0" cy="0"/>
+        </a:xfrm>
+      </p:grpSpPr>
       <p:sp>
         <p:nvSpPr>
           <p:cNvPr id="2" name="TextBox 1"/>
@@ -4269,8 +4318,8 @@
         </p:nvSpPr>
         <p:spPr>
           <a:xfrm>
-            <a:off x="822960" y="548640"/>
-            <a:ext cx="10545775" cy="1097280"/>
+            <a:off x="822960" y="660545"/>
+            <a:ext cx="10545775" cy="738664"/>
           </a:xfrm>
           <a:prstGeom prst="rect">
             <a:avLst/>
@@ -4278,46 +4327,23 @@
           <a:noFill/>
         </p:spPr>
         <p:txBody>
-          <a:bodyPr wrap="square" lIns="0" rIns="0" tIns="0" bIns="0">
+          <a:bodyPr wrap="square" lIns="0" tIns="0" rIns="0" bIns="0">
             <a:spAutoFit/>
           </a:bodyPr>
           <a:lstStyle/>
           <a:p>
-            <a:pPr algn="l">
-              <a:lnSpc>
-                <a:spcPct val="100000"/>
-              </a:lnSpc>
+            <a:pPr>
               <a:spcAft>
                 <a:spcPts val="700"/>
               </a:spcAft>
             </a:pPr>
             <a:r>
-              <a:rPr sz="1200" b="1">
+              <a:rPr lang="en-US" sz="4800" b="1" dirty="0">
                 <a:solidFill>
                   <a:srgbClr val="1F7A6B"/>
                 </a:solidFill>
-                <a:latin typeface="Calibri"/>
-              </a:rPr>
-              <a:t>THE QUESTION</a:t>
-            </a:r>
-          </a:p>
-          <a:p>
-            <a:pPr algn="l">
-              <a:lnSpc>
-                <a:spcPct val="100000"/>
-              </a:lnSpc>
-              <a:spcAft>
-                <a:spcPts val="0"/>
-              </a:spcAft>
-            </a:pPr>
-            <a:r>
-              <a:rPr sz="3100" b="1">
-                <a:solidFill>
-                  <a:srgbClr val="0B2545"/>
-                </a:solidFill>
-                <a:latin typeface="Calibri"/>
-              </a:rPr>
-              <a:t>What the model is actually asked</a:t>
+              </a:rPr>
+              <a:t>QUESTION</a:t>
             </a:r>
           </a:p>
         </p:txBody>
@@ -4363,6 +4389,7 @@
           <a:lstStyle/>
           <a:p>
             <a:pPr algn="ctr"/>
+            <a:endParaRPr/>
           </a:p>
         </p:txBody>
       </p:sp>
@@ -4383,7 +4410,7 @@
           <a:noFill/>
         </p:spPr>
         <p:txBody>
-          <a:bodyPr wrap="square" lIns="0" rIns="0" tIns="0" bIns="0">
+          <a:bodyPr wrap="square" lIns="0" tIns="0" rIns="0" bIns="0">
             <a:spAutoFit/>
           </a:bodyPr>
           <a:lstStyle/>
@@ -4416,8 +4443,8 @@
         </p:nvSpPr>
         <p:spPr>
           <a:xfrm>
-            <a:off x="822960" y="2057400"/>
-            <a:ext cx="10545775" cy="3886200"/>
+            <a:off x="822960" y="2607102"/>
+            <a:ext cx="9792789" cy="1099404"/>
           </a:xfrm>
           <a:prstGeom prst="rect">
             <a:avLst/>
@@ -4425,7 +4452,7 @@
           <a:noFill/>
         </p:spPr>
         <p:txBody>
-          <a:bodyPr wrap="square" lIns="0" rIns="0" tIns="0" bIns="0">
+          <a:bodyPr wrap="square" lIns="0" tIns="0" rIns="0" bIns="0">
             <a:spAutoFit/>
           </a:bodyPr>
           <a:lstStyle/>
@@ -4439,106 +4466,22 @@
               </a:spcAft>
             </a:pPr>
             <a:r>
-              <a:rPr sz="1600" b="1">
-                <a:solidFill>
-                  <a:srgbClr val="0B2545"/>
-                </a:solidFill>
-                <a:latin typeface="Calibri"/>
-              </a:rPr>
-              <a:t>For one truck, right now:</a:t>
-            </a:r>
-            <a:r>
-              <a:rPr sz="1600">
+              <a:rPr lang="en-US" sz="3200" b="1" dirty="0">
                 <a:solidFill>
                   <a:srgbClr val="343D4A"/>
                 </a:solidFill>
                 <a:latin typeface="Calibri"/>
               </a:rPr>
-              <a:t>  how close is the monitored component to failure, using only the readouts that truck has already sent home.</a:t>
-            </a:r>
-          </a:p>
-          <a:p>
-            <a:pPr algn="l">
-              <a:lnSpc>
-                <a:spcPct val="115000"/>
-              </a:lnSpc>
-              <a:spcAft>
-                <a:spcPts val="1400"/>
-              </a:spcAft>
-            </a:pPr>
-            <a:r>
-              <a:rPr sz="1600" b="1">
-                <a:solidFill>
-                  <a:srgbClr val="0B2545"/>
-                </a:solidFill>
-                <a:latin typeface="Calibri"/>
-              </a:rPr>
-              <a:t>The output is an action, not a score:</a:t>
-            </a:r>
-            <a:r>
-              <a:rPr sz="1600">
+              <a:t>H</a:t>
+            </a:r>
+            <a:r>
+              <a:rPr sz="3200" b="1" dirty="0">
                 <a:solidFill>
                   <a:srgbClr val="343D4A"/>
                 </a:solidFill>
                 <a:latin typeface="Calibri"/>
               </a:rPr>
-              <a:t>  call this truck into the workshop, or leave it running.</a:t>
-            </a:r>
-          </a:p>
-          <a:p>
-            <a:pPr algn="l">
-              <a:lnSpc>
-                <a:spcPct val="115000"/>
-              </a:lnSpc>
-              <a:spcAft>
-                <a:spcPts val="1400"/>
-              </a:spcAft>
-            </a:pPr>
-            <a:r>
-              <a:rPr sz="1600" b="1">
-                <a:solidFill>
-                  <a:srgbClr val="0B2545"/>
-                </a:solidFill>
-                <a:latin typeface="Calibri"/>
-              </a:rPr>
-              <a:t>Five degradation classes:</a:t>
-            </a:r>
-            <a:r>
-              <a:rPr sz="1600">
-                <a:solidFill>
-                  <a:srgbClr val="343D4A"/>
-                </a:solidFill>
-                <a:latin typeface="Calibri"/>
-              </a:rPr>
-              <a:t>  class 0 is more than 48 time steps from failure, class 4 is 0 to 6 steps away.</a:t>
-            </a:r>
-          </a:p>
-          <a:p>
-            <a:pPr algn="l">
-              <a:lnSpc>
-                <a:spcPct val="115000"/>
-              </a:lnSpc>
-              <a:spcAft>
-                <a:spcPts val="1400"/>
-              </a:spcAft>
-            </a:pPr>
-            <a:r>
-              <a:rPr sz="1600" b="1">
-                <a:solidFill>
-                  <a:srgbClr val="0B2545"/>
-                </a:solidFill>
-                <a:latin typeface="Calibri"/>
-              </a:rPr>
-              <a:t>Only 2.7% of the fleet is at risk</a:t>
-            </a:r>
-            <a:r>
-              <a:rPr sz="1600">
-                <a:solidFill>
-                  <a:srgbClr val="343D4A"/>
-                </a:solidFill>
-                <a:latin typeface="Calibri"/>
-              </a:rPr>
-              <a:t>  in any scoring window. The rest are healthy and must not be disturbed.</a:t>
+              <a:t>ow close is the monitored component to failure, using only the readouts that truck has already sent home.</a:t>
             </a:r>
           </a:p>
         </p:txBody>
@@ -4552,7 +4495,7 @@
 </file>
 
 <file path=ppt/slides/slide3.xml><?xml version="1.0" encoding="utf-8"?>
-<p:sld xmlns:a="http://schemas.openxmlformats.org/drawingml/2006/main" xmlns:p="http://schemas.openxmlformats.org/presentationml/2006/main" xmlns:r="http://schemas.openxmlformats.org/officeDocument/2006/relationships">
+<p:sld xmlns:a="http://schemas.openxmlformats.org/drawingml/2006/main" xmlns:r="http://schemas.openxmlformats.org/officeDocument/2006/relationships" xmlns:p="http://schemas.openxmlformats.org/presentationml/2006/main">
   <p:cSld>
     <p:spTree>
       <p:nvGrpSpPr>
@@ -4560,7 +4503,14 @@
         <p:cNvGrpSpPr/>
         <p:nvPr/>
       </p:nvGrpSpPr>
-      <p:grpSpPr/>
+      <p:grpSpPr>
+        <a:xfrm>
+          <a:off x="0" y="0"/>
+          <a:ext cx="0" cy="0"/>
+          <a:chOff x="0" y="0"/>
+          <a:chExt cx="0" cy="0"/>
+        </a:xfrm>
+      </p:grpSpPr>
       <p:sp>
         <p:nvSpPr>
           <p:cNvPr id="2" name="TextBox 1"/>
@@ -4570,7 +4520,7 @@
         <p:spPr>
           <a:xfrm>
             <a:off x="822960" y="548640"/>
-            <a:ext cx="10545775" cy="1097280"/>
+            <a:ext cx="10545775" cy="738664"/>
           </a:xfrm>
           <a:prstGeom prst="rect">
             <a:avLst/>
@@ -4578,7 +4528,7 @@
           <a:noFill/>
         </p:spPr>
         <p:txBody>
-          <a:bodyPr wrap="square" lIns="0" rIns="0" tIns="0" bIns="0">
+          <a:bodyPr wrap="square" lIns="0" tIns="0" rIns="0" bIns="0">
             <a:spAutoFit/>
           </a:bodyPr>
           <a:lstStyle/>
@@ -4592,32 +4542,13 @@
               </a:spcAft>
             </a:pPr>
             <a:r>
-              <a:rPr sz="1200" b="1">
+              <a:rPr sz="4800" b="1" dirty="0">
                 <a:solidFill>
                   <a:srgbClr val="1F7A6B"/>
                 </a:solidFill>
                 <a:latin typeface="Calibri"/>
               </a:rPr>
               <a:t>WHY ACCURACY FAILS</a:t>
-            </a:r>
-          </a:p>
-          <a:p>
-            <a:pPr algn="l">
-              <a:lnSpc>
-                <a:spcPct val="100000"/>
-              </a:lnSpc>
-              <a:spcAft>
-                <a:spcPts val="0"/>
-              </a:spcAft>
-            </a:pPr>
-            <a:r>
-              <a:rPr sz="3100" b="1">
-                <a:solidFill>
-                  <a:srgbClr val="0B2545"/>
-                </a:solidFill>
-                <a:latin typeface="Calibri"/>
-              </a:rPr>
-              <a:t>The economics decide the model, not the metric</a:t>
             </a:r>
           </a:p>
         </p:txBody>
@@ -4663,6 +4594,7 @@
           <a:lstStyle/>
           <a:p>
             <a:pPr algn="ctr"/>
+            <a:endParaRPr/>
           </a:p>
         </p:txBody>
       </p:sp>
@@ -4683,7 +4615,7 @@
           <a:noFill/>
         </p:spPr>
         <p:txBody>
-          <a:bodyPr wrap="square" lIns="0" rIns="0" tIns="0" bIns="0">
+          <a:bodyPr wrap="square" lIns="0" tIns="0" rIns="0" bIns="0">
             <a:spAutoFit/>
           </a:bodyPr>
           <a:lstStyle/>
@@ -4710,22 +4642,404 @@
       </p:sp>
       <p:sp>
         <p:nvSpPr>
-          <p:cNvPr id="5" name="Rounded Rectangle 4"/>
+          <p:cNvPr id="6" name="TextBox 5"/>
+          <p:cNvSpPr txBox="1"/>
+          <p:nvPr/>
+        </p:nvSpPr>
+        <p:spPr>
+          <a:xfrm>
+            <a:off x="822960" y="2313432"/>
+            <a:ext cx="2753258" cy="1167627"/>
+          </a:xfrm>
+          <a:prstGeom prst="rect">
+            <a:avLst/>
+          </a:prstGeom>
+          <a:noFill/>
+        </p:spPr>
+        <p:txBody>
+          <a:bodyPr wrap="square" lIns="0" tIns="0" rIns="0" bIns="0">
+            <a:spAutoFit/>
+          </a:bodyPr>
+          <a:lstStyle/>
+          <a:p>
+            <a:pPr algn="l">
+              <a:lnSpc>
+                <a:spcPct val="100000"/>
+              </a:lnSpc>
+              <a:spcAft>
+                <a:spcPts val="400"/>
+              </a:spcAft>
+            </a:pPr>
+            <a:r>
+              <a:rPr sz="6000" b="1" dirty="0">
+                <a:solidFill>
+                  <a:srgbClr val="B5481E"/>
+                </a:solidFill>
+                <a:latin typeface="Calibri"/>
+              </a:rPr>
+              <a:t>500</a:t>
+            </a:r>
+          </a:p>
+          <a:p>
+            <a:pPr algn="l">
+              <a:lnSpc>
+                <a:spcPct val="110000"/>
+              </a:lnSpc>
+              <a:spcAft>
+                <a:spcPts val="0"/>
+              </a:spcAft>
+            </a:pPr>
+            <a:r>
+              <a:rPr sz="1200" b="0" dirty="0">
+                <a:solidFill>
+                  <a:srgbClr val="8A94A0"/>
+                </a:solidFill>
+                <a:latin typeface="Calibri"/>
+              </a:rPr>
+              <a:t>Cost of missing a truck that fails</a:t>
+            </a:r>
+          </a:p>
+        </p:txBody>
+      </p:sp>
+      <p:sp>
+        <p:nvSpPr>
+          <p:cNvPr id="8" name="TextBox 7"/>
+          <p:cNvSpPr txBox="1"/>
+          <p:nvPr/>
+        </p:nvSpPr>
+        <p:spPr>
+          <a:xfrm>
+            <a:off x="4231538" y="2313432"/>
+            <a:ext cx="2753258" cy="1167627"/>
+          </a:xfrm>
+          <a:prstGeom prst="rect">
+            <a:avLst/>
+          </a:prstGeom>
+          <a:noFill/>
+        </p:spPr>
+        <p:txBody>
+          <a:bodyPr wrap="square" lIns="0" tIns="0" rIns="0" bIns="0">
+            <a:spAutoFit/>
+          </a:bodyPr>
+          <a:lstStyle/>
+          <a:p>
+            <a:pPr algn="l">
+              <a:lnSpc>
+                <a:spcPct val="100000"/>
+              </a:lnSpc>
+              <a:spcAft>
+                <a:spcPts val="400"/>
+              </a:spcAft>
+            </a:pPr>
+            <a:r>
+              <a:rPr sz="6000" b="1" dirty="0">
+                <a:solidFill>
+                  <a:srgbClr val="1F7A6B"/>
+                </a:solidFill>
+                <a:latin typeface="Calibri"/>
+              </a:rPr>
+              <a:t>10</a:t>
+            </a:r>
+          </a:p>
+          <a:p>
+            <a:pPr algn="l">
+              <a:lnSpc>
+                <a:spcPct val="110000"/>
+              </a:lnSpc>
+              <a:spcAft>
+                <a:spcPts val="0"/>
+              </a:spcAft>
+            </a:pPr>
+            <a:r>
+              <a:rPr sz="1200" b="0" dirty="0">
+                <a:solidFill>
+                  <a:srgbClr val="8A94A0"/>
+                </a:solidFill>
+                <a:latin typeface="Calibri"/>
+              </a:rPr>
+              <a:t>Cost of a workshop check that finds nothing</a:t>
+            </a:r>
+          </a:p>
+        </p:txBody>
+      </p:sp>
+      <p:sp>
+        <p:nvSpPr>
+          <p:cNvPr id="10" name="TextBox 9"/>
+          <p:cNvSpPr txBox="1"/>
+          <p:nvPr/>
+        </p:nvSpPr>
+        <p:spPr>
+          <a:xfrm>
+            <a:off x="8106024" y="2313432"/>
+            <a:ext cx="2753258" cy="1167627"/>
+          </a:xfrm>
+          <a:prstGeom prst="rect">
+            <a:avLst/>
+          </a:prstGeom>
+          <a:noFill/>
+        </p:spPr>
+        <p:txBody>
+          <a:bodyPr wrap="square" lIns="0" tIns="0" rIns="0" bIns="0">
+            <a:spAutoFit/>
+          </a:bodyPr>
+          <a:lstStyle/>
+          <a:p>
+            <a:pPr algn="l">
+              <a:lnSpc>
+                <a:spcPct val="100000"/>
+              </a:lnSpc>
+              <a:spcAft>
+                <a:spcPts val="400"/>
+              </a:spcAft>
+            </a:pPr>
+            <a:r>
+              <a:rPr sz="6000" b="1" dirty="0">
+                <a:solidFill>
+                  <a:srgbClr val="0B2545"/>
+                </a:solidFill>
+                <a:latin typeface="Calibri"/>
+              </a:rPr>
+              <a:t>50 : 1</a:t>
+            </a:r>
+          </a:p>
+          <a:p>
+            <a:pPr algn="l">
+              <a:lnSpc>
+                <a:spcPct val="110000"/>
+              </a:lnSpc>
+              <a:spcAft>
+                <a:spcPts val="0"/>
+              </a:spcAft>
+            </a:pPr>
+            <a:r>
+              <a:rPr sz="1200" b="0" dirty="0">
+                <a:solidFill>
+                  <a:srgbClr val="8A94A0"/>
+                </a:solidFill>
+                <a:latin typeface="Calibri"/>
+              </a:rPr>
+              <a:t>False alarms one real catch pays for</a:t>
+            </a:r>
+          </a:p>
+        </p:txBody>
+      </p:sp>
+      <p:sp>
+        <p:nvSpPr>
+          <p:cNvPr id="11" name="TextBox 10"/>
+          <p:cNvSpPr txBox="1"/>
+          <p:nvPr/>
+        </p:nvSpPr>
+        <p:spPr>
+          <a:xfrm>
+            <a:off x="822960" y="4102804"/>
+            <a:ext cx="10545775" cy="1012328"/>
+          </a:xfrm>
+          <a:prstGeom prst="rect">
+            <a:avLst/>
+          </a:prstGeom>
+          <a:noFill/>
+        </p:spPr>
+        <p:txBody>
+          <a:bodyPr wrap="square" lIns="0" tIns="0" rIns="0" bIns="0">
+            <a:spAutoFit/>
+          </a:bodyPr>
+          <a:lstStyle/>
+          <a:p>
+            <a:pPr algn="l">
+              <a:lnSpc>
+                <a:spcPct val="115000"/>
+              </a:lnSpc>
+              <a:spcAft>
+                <a:spcPts val="1400"/>
+              </a:spcAft>
+            </a:pPr>
+            <a:r>
+              <a:rPr sz="1600" b="1" dirty="0">
+                <a:solidFill>
+                  <a:srgbClr val="0B2545"/>
+                </a:solidFill>
+                <a:latin typeface="Calibri"/>
+              </a:rPr>
+              <a:t>A model scored on accuracy predicts healthy for everyone,</a:t>
+            </a:r>
+            <a:r>
+              <a:rPr sz="1600" dirty="0">
+                <a:solidFill>
+                  <a:srgbClr val="343D4A"/>
+                </a:solidFill>
+                <a:latin typeface="Calibri"/>
+              </a:rPr>
+              <a:t>  is right 97% of the time and saves nothing.</a:t>
+            </a:r>
+          </a:p>
+          <a:p>
+            <a:pPr algn="l">
+              <a:lnSpc>
+                <a:spcPct val="115000"/>
+              </a:lnSpc>
+              <a:spcAft>
+                <a:spcPts val="1400"/>
+              </a:spcAft>
+            </a:pPr>
+            <a:r>
+              <a:rPr sz="1600" b="1" dirty="0">
+                <a:solidFill>
+                  <a:srgbClr val="0B2545"/>
+                </a:solidFill>
+                <a:latin typeface="Calibri"/>
+              </a:rPr>
+              <a:t>We </a:t>
+            </a:r>
+            <a:r>
+              <a:rPr sz="1600" b="1" dirty="0" err="1">
+                <a:solidFill>
+                  <a:srgbClr val="0B2545"/>
+                </a:solidFill>
+                <a:latin typeface="Calibri"/>
+              </a:rPr>
+              <a:t>minimise</a:t>
+            </a:r>
+            <a:r>
+              <a:rPr sz="1600" b="1" dirty="0">
+                <a:solidFill>
+                  <a:srgbClr val="0B2545"/>
+                </a:solidFill>
+                <a:latin typeface="Calibri"/>
+              </a:rPr>
+              <a:t> expected cost instead.</a:t>
+            </a:r>
+            <a:r>
+              <a:rPr sz="1600" dirty="0">
+                <a:solidFill>
+                  <a:srgbClr val="343D4A"/>
+                </a:solidFill>
+                <a:latin typeface="Calibri"/>
+              </a:rPr>
+              <a:t>  The model emits probabilities</a:t>
+            </a:r>
+            <a:r>
+              <a:rPr lang="en-US" sz="1600" dirty="0">
+                <a:solidFill>
+                  <a:srgbClr val="343D4A"/>
+                </a:solidFill>
+                <a:latin typeface="Calibri"/>
+              </a:rPr>
+              <a:t> and</a:t>
+            </a:r>
+            <a:r>
+              <a:rPr sz="1600" dirty="0">
+                <a:solidFill>
+                  <a:srgbClr val="343D4A"/>
+                </a:solidFill>
+                <a:latin typeface="Calibri"/>
+              </a:rPr>
+              <a:t> the decision rule picks the cheapest action under the published cost matrix.</a:t>
+            </a:r>
+          </a:p>
+        </p:txBody>
+      </p:sp>
+    </p:spTree>
+  </p:cSld>
+  <p:clrMapOvr>
+    <a:masterClrMapping/>
+  </p:clrMapOvr>
+</p:sld>
+</file>
+
+<file path=ppt/slides/slide4.xml><?xml version="1.0" encoding="utf-8"?>
+<p:sld xmlns:a="http://schemas.openxmlformats.org/drawingml/2006/main" xmlns:r="http://schemas.openxmlformats.org/officeDocument/2006/relationships" xmlns:p="http://schemas.openxmlformats.org/presentationml/2006/main">
+  <p:cSld>
+    <p:spTree>
+      <p:nvGrpSpPr>
+        <p:cNvPr id="1" name=""/>
+        <p:cNvGrpSpPr/>
+        <p:nvPr/>
+      </p:nvGrpSpPr>
+      <p:grpSpPr>
+        <a:xfrm>
+          <a:off x="0" y="0"/>
+          <a:ext cx="0" cy="0"/>
+          <a:chOff x="0" y="0"/>
+          <a:chExt cx="0" cy="0"/>
+        </a:xfrm>
+      </p:grpSpPr>
+      <p:sp>
+        <p:nvSpPr>
+          <p:cNvPr id="2" name="TextBox 1"/>
+          <p:cNvSpPr txBox="1"/>
+          <p:nvPr/>
+        </p:nvSpPr>
+        <p:spPr>
+          <a:xfrm>
+            <a:off x="822960" y="548640"/>
+            <a:ext cx="10545775" cy="1097280"/>
+          </a:xfrm>
+          <a:prstGeom prst="rect">
+            <a:avLst/>
+          </a:prstGeom>
+          <a:noFill/>
+        </p:spPr>
+        <p:txBody>
+          <a:bodyPr wrap="square" lIns="0" tIns="0" rIns="0" bIns="0">
+            <a:spAutoFit/>
+          </a:bodyPr>
+          <a:lstStyle/>
+          <a:p>
+            <a:pPr algn="l">
+              <a:lnSpc>
+                <a:spcPct val="100000"/>
+              </a:lnSpc>
+              <a:spcAft>
+                <a:spcPts val="700"/>
+              </a:spcAft>
+            </a:pPr>
+            <a:r>
+              <a:rPr sz="1200" b="1">
+                <a:solidFill>
+                  <a:srgbClr val="1F7A6B"/>
+                </a:solidFill>
+                <a:latin typeface="Calibri"/>
+              </a:rPr>
+              <a:t>RESULT</a:t>
+            </a:r>
+          </a:p>
+          <a:p>
+            <a:pPr algn="l">
+              <a:lnSpc>
+                <a:spcPct val="100000"/>
+              </a:lnSpc>
+              <a:spcAft>
+                <a:spcPts val="0"/>
+              </a:spcAft>
+            </a:pPr>
+            <a:r>
+              <a:rPr sz="3100" b="1">
+                <a:solidFill>
+                  <a:srgbClr val="0B2545"/>
+                </a:solidFill>
+                <a:latin typeface="Calibri"/>
+              </a:rPr>
+              <a:t>Cost against every alternative policy</a:t>
+            </a:r>
+          </a:p>
+        </p:txBody>
+      </p:sp>
+      <p:sp>
+        <p:nvSpPr>
+          <p:cNvPr id="3" name="Rectangle 2"/>
           <p:cNvSpPr/>
           <p:nvPr/>
         </p:nvSpPr>
         <p:spPr>
           <a:xfrm>
-            <a:off x="822960" y="2057400"/>
-            <a:ext cx="3301898" cy="1508760"/>
-          </a:xfrm>
-          <a:prstGeom prst="roundRect">
-            <a:avLst>
-              <a:gd name="adj" fmla="val 5000"/>
-            </a:avLst>
+            <a:off x="822960" y="1783080"/>
+            <a:ext cx="10545775" cy="15875"/>
+          </a:xfrm>
+          <a:prstGeom prst="rect">
+            <a:avLst/>
           </a:prstGeom>
           <a:solidFill>
-            <a:srgbClr val="F4F7F9"/>
+            <a:srgbClr val="DDE3E9"/>
           </a:solidFill>
           <a:ln>
             <a:noFill/>
@@ -4751,19 +5065,20 @@
           <a:lstStyle/>
           <a:p>
             <a:pPr algn="ctr"/>
-          </a:p>
-        </p:txBody>
-      </p:sp>
-      <p:sp>
-        <p:nvSpPr>
-          <p:cNvPr id="6" name="TextBox 5"/>
+            <a:endParaRPr/>
+          </a:p>
+        </p:txBody>
+      </p:sp>
+      <p:sp>
+        <p:nvSpPr>
+          <p:cNvPr id="4" name="TextBox 3"/>
           <p:cNvSpPr txBox="1"/>
           <p:nvPr/>
         </p:nvSpPr>
         <p:spPr>
           <a:xfrm>
-            <a:off x="1097280" y="2313432"/>
-            <a:ext cx="2753258" cy="1097280"/>
+            <a:off x="822960" y="6291072"/>
+            <a:ext cx="10545775" cy="274320"/>
           </a:xfrm>
           <a:prstGeom prst="rect">
             <a:avLst/>
@@ -4771,7 +5086,7 @@
           <a:noFill/>
         </p:spPr>
         <p:txBody>
-          <a:bodyPr wrap="square" lIns="0" rIns="0" tIns="0" bIns="0">
+          <a:bodyPr wrap="square" lIns="0" tIns="0" rIns="0" bIns="0">
             <a:spAutoFit/>
           </a:bodyPr>
           <a:lstStyle/>
@@ -4781,96 +5096,31 @@
                 <a:spcPct val="100000"/>
               </a:lnSpc>
               <a:spcAft>
-                <a:spcPts val="400"/>
-              </a:spcAft>
-            </a:pPr>
-            <a:r>
-              <a:rPr sz="3400" b="1">
-                <a:solidFill>
-                  <a:srgbClr val="B5481E"/>
-                </a:solidFill>
-                <a:latin typeface="Calibri"/>
-              </a:rPr>
-              <a:t>500</a:t>
-            </a:r>
-          </a:p>
-          <a:p>
-            <a:pPr algn="l">
-              <a:lnSpc>
-                <a:spcPct val="110000"/>
-              </a:lnSpc>
-              <a:spcAft>
                 <a:spcPts val="0"/>
               </a:spcAft>
             </a:pPr>
             <a:r>
-              <a:rPr sz="1200" b="0">
+              <a:rPr sz="1000" b="0">
                 <a:solidFill>
                   <a:srgbClr val="8A94A0"/>
                 </a:solidFill>
                 <a:latin typeface="Calibri"/>
               </a:rPr>
-              <a:t>Cost of missing a truck that fails</a:t>
-            </a:r>
-          </a:p>
-        </p:txBody>
-      </p:sp>
-      <p:sp>
-        <p:nvSpPr>
-          <p:cNvPr id="7" name="Rounded Rectangle 6"/>
-          <p:cNvSpPr/>
-          <p:nvPr/>
-        </p:nvSpPr>
-        <p:spPr>
-          <a:xfrm>
-            <a:off x="4444898" y="2057400"/>
-            <a:ext cx="3301898" cy="1508760"/>
-          </a:xfrm>
-          <a:prstGeom prst="roundRect">
-            <a:avLst>
-              <a:gd name="adj" fmla="val 5000"/>
-            </a:avLst>
-          </a:prstGeom>
-          <a:solidFill>
-            <a:srgbClr val="F4F7F9"/>
-          </a:solidFill>
-          <a:ln>
-            <a:noFill/>
-          </a:ln>
-          <a:effectLst/>
-        </p:spPr>
-        <p:style>
-          <a:lnRef idx="1">
-            <a:schemeClr val="accent1"/>
-          </a:lnRef>
-          <a:fillRef idx="3">
-            <a:schemeClr val="accent1"/>
-          </a:fillRef>
-          <a:effectRef idx="2">
-            <a:schemeClr val="accent1"/>
-          </a:effectRef>
-          <a:fontRef idx="minor">
-            <a:schemeClr val="lt1"/>
-          </a:fontRef>
-        </p:style>
-        <p:txBody>
-          <a:bodyPr rtlCol="0" anchor="ctr"/>
-          <a:lstStyle/>
-          <a:p>
-            <a:pPr algn="ctr"/>
-          </a:p>
-        </p:txBody>
-      </p:sp>
-      <p:sp>
-        <p:nvSpPr>
-          <p:cNvPr id="8" name="TextBox 7"/>
+              <a:t>SCANIA Component X   |   04</a:t>
+            </a:r>
+          </a:p>
+        </p:txBody>
+      </p:sp>
+      <p:sp>
+        <p:nvSpPr>
+          <p:cNvPr id="6" name="TextBox 5"/>
           <p:cNvSpPr txBox="1"/>
           <p:nvPr/>
         </p:nvSpPr>
         <p:spPr>
           <a:xfrm>
-            <a:off x="4719218" y="2313432"/>
-            <a:ext cx="2753258" cy="1097280"/>
+            <a:off x="1097280" y="2313432"/>
+            <a:ext cx="2753258" cy="767518"/>
           </a:xfrm>
           <a:prstGeom prst="rect">
             <a:avLst/>
@@ -4878,7 +5128,7 @@
           <a:noFill/>
         </p:spPr>
         <p:txBody>
-          <a:bodyPr wrap="square" lIns="0" rIns="0" tIns="0" bIns="0">
+          <a:bodyPr wrap="square" lIns="0" tIns="0" rIns="0" bIns="0">
             <a:spAutoFit/>
           </a:bodyPr>
           <a:lstStyle/>
@@ -4892,13 +5142,13 @@
               </a:spcAft>
             </a:pPr>
             <a:r>
-              <a:rPr sz="3400" b="1">
+              <a:rPr sz="3400" b="1" dirty="0">
                 <a:solidFill>
                   <a:srgbClr val="1F7A6B"/>
                 </a:solidFill>
                 <a:latin typeface="Calibri"/>
               </a:rPr>
-              <a:t>10</a:t>
+              <a:t>35,469 ± 849</a:t>
             </a:r>
           </a:p>
           <a:p>
@@ -4911,72 +5161,26 @@
               </a:spcAft>
             </a:pPr>
             <a:r>
-              <a:rPr sz="1200" b="0">
+              <a:rPr sz="1200" b="0" dirty="0">
                 <a:solidFill>
                   <a:srgbClr val="8A94A0"/>
                 </a:solidFill>
                 <a:latin typeface="Calibri"/>
               </a:rPr>
-              <a:t>Cost of a workshop check that finds nothing</a:t>
-            </a:r>
-          </a:p>
-        </p:txBody>
-      </p:sp>
-      <p:sp>
-        <p:nvSpPr>
-          <p:cNvPr id="9" name="Rounded Rectangle 8"/>
-          <p:cNvSpPr/>
-          <p:nvPr/>
-        </p:nvSpPr>
-        <p:spPr>
-          <a:xfrm>
-            <a:off x="8066836" y="2057400"/>
-            <a:ext cx="3301898" cy="1508760"/>
-          </a:xfrm>
-          <a:prstGeom prst="roundRect">
-            <a:avLst>
-              <a:gd name="adj" fmla="val 5000"/>
-            </a:avLst>
-          </a:prstGeom>
-          <a:solidFill>
-            <a:srgbClr val="F4F7F9"/>
-          </a:solidFill>
-          <a:ln>
-            <a:noFill/>
-          </a:ln>
-          <a:effectLst/>
-        </p:spPr>
-        <p:style>
-          <a:lnRef idx="1">
-            <a:schemeClr val="accent1"/>
-          </a:lnRef>
-          <a:fillRef idx="3">
-            <a:schemeClr val="accent1"/>
-          </a:fillRef>
-          <a:effectRef idx="2">
-            <a:schemeClr val="accent1"/>
-          </a:effectRef>
-          <a:fontRef idx="minor">
-            <a:schemeClr val="lt1"/>
-          </a:fontRef>
-        </p:style>
-        <p:txBody>
-          <a:bodyPr rtlCol="0" anchor="ctr"/>
-          <a:lstStyle/>
-          <a:p>
-            <a:pPr algn="ctr"/>
-          </a:p>
-        </p:txBody>
-      </p:sp>
-      <p:sp>
-        <p:nvSpPr>
-          <p:cNvPr id="10" name="TextBox 9"/>
+              <a:t>Test cost</a:t>
+            </a:r>
+          </a:p>
+        </p:txBody>
+      </p:sp>
+      <p:sp>
+        <p:nvSpPr>
+          <p:cNvPr id="8" name="TextBox 7"/>
           <p:cNvSpPr txBox="1"/>
           <p:nvPr/>
         </p:nvSpPr>
         <p:spPr>
           <a:xfrm>
-            <a:off x="8341156" y="2313432"/>
+            <a:off x="4719218" y="2313432"/>
             <a:ext cx="2753258" cy="1097280"/>
           </a:xfrm>
           <a:prstGeom prst="rect">
@@ -4985,7 +5189,7 @@
           <a:noFill/>
         </p:spPr>
         <p:txBody>
-          <a:bodyPr wrap="square" lIns="0" rIns="0" tIns="0" bIns="0">
+          <a:bodyPr wrap="square" lIns="0" tIns="0" rIns="0" bIns="0">
             <a:spAutoFit/>
           </a:bodyPr>
           <a:lstStyle/>
@@ -5005,7 +5209,7 @@
                 </a:solidFill>
                 <a:latin typeface="Calibri"/>
               </a:rPr>
-              <a:t>50 : 1</a:t>
+              <a:t>29%</a:t>
             </a:r>
           </a:p>
           <a:p>
@@ -5024,21 +5228,21 @@
                 </a:solidFill>
                 <a:latin typeface="Calibri"/>
               </a:rPr>
-              <a:t>False alarms one real catch pays for</a:t>
-            </a:r>
-          </a:p>
-        </p:txBody>
-      </p:sp>
-      <p:sp>
-        <p:nvSpPr>
-          <p:cNvPr id="11" name="TextBox 10"/>
+              <a:t>Cheaper than checking every truck</a:t>
+            </a:r>
+          </a:p>
+        </p:txBody>
+      </p:sp>
+      <p:sp>
+        <p:nvSpPr>
+          <p:cNvPr id="10" name="TextBox 9"/>
           <p:cNvSpPr txBox="1"/>
           <p:nvPr/>
         </p:nvSpPr>
         <p:spPr>
           <a:xfrm>
-            <a:off x="822960" y="3977640"/>
-            <a:ext cx="10545775" cy="1965960"/>
+            <a:off x="8341156" y="2313432"/>
+            <a:ext cx="2753258" cy="1097280"/>
           </a:xfrm>
           <a:prstGeom prst="rect">
             <a:avLst/>
@@ -5046,539 +5250,7 @@
           <a:noFill/>
         </p:spPr>
         <p:txBody>
-          <a:bodyPr wrap="square" lIns="0" rIns="0" tIns="0" bIns="0">
-            <a:spAutoFit/>
-          </a:bodyPr>
-          <a:lstStyle/>
-          <a:p>
-            <a:pPr algn="l">
-              <a:lnSpc>
-                <a:spcPct val="115000"/>
-              </a:lnSpc>
-              <a:spcAft>
-                <a:spcPts val="1400"/>
-              </a:spcAft>
-            </a:pPr>
-            <a:r>
-              <a:rPr sz="1600" b="1">
-                <a:solidFill>
-                  <a:srgbClr val="0B2545"/>
-                </a:solidFill>
-                <a:latin typeface="Calibri"/>
-              </a:rPr>
-              <a:t>A model scored on accuracy predicts healthy for everyone,</a:t>
-            </a:r>
-            <a:r>
-              <a:rPr sz="1600">
-                <a:solidFill>
-                  <a:srgbClr val="343D4A"/>
-                </a:solidFill>
-                <a:latin typeface="Calibri"/>
-              </a:rPr>
-              <a:t>  is right 97% of the time, and saves nothing.</a:t>
-            </a:r>
-          </a:p>
-          <a:p>
-            <a:pPr algn="l">
-              <a:lnSpc>
-                <a:spcPct val="115000"/>
-              </a:lnSpc>
-              <a:spcAft>
-                <a:spcPts val="1400"/>
-              </a:spcAft>
-            </a:pPr>
-            <a:r>
-              <a:rPr sz="1600" b="1">
-                <a:solidFill>
-                  <a:srgbClr val="0B2545"/>
-                </a:solidFill>
-                <a:latin typeface="Calibri"/>
-              </a:rPr>
-              <a:t>We minimise expected cost instead.</a:t>
-            </a:r>
-            <a:r>
-              <a:rPr sz="1600">
-                <a:solidFill>
-                  <a:srgbClr val="343D4A"/>
-                </a:solidFill>
-                <a:latin typeface="Calibri"/>
-              </a:rPr>
-              <a:t>  The model emits probabilities; the decision rule picks the cheapest action under the published cost matrix.</a:t>
-            </a:r>
-          </a:p>
-          <a:p>
-            <a:pPr algn="l">
-              <a:lnSpc>
-                <a:spcPct val="115000"/>
-              </a:lnSpc>
-              <a:spcAft>
-                <a:spcPts val="1400"/>
-              </a:spcAft>
-            </a:pPr>
-            <a:r>
-              <a:rPr sz="1600" b="1">
-                <a:solidFill>
-                  <a:srgbClr val="0B2545"/>
-                </a:solidFill>
-                <a:latin typeface="Calibri"/>
-              </a:rPr>
-              <a:t>Low precision is correct here, not broken.</a:t>
-            </a:r>
-            <a:r>
-              <a:rPr sz="1600">
-                <a:solidFill>
-                  <a:srgbClr val="343D4A"/>
-                </a:solidFill>
-                <a:latin typeface="Calibri"/>
-              </a:rPr>
-              <a:t>  Optimising precision on this loss destroys value.</a:t>
-            </a:r>
-          </a:p>
-        </p:txBody>
-      </p:sp>
-    </p:spTree>
-  </p:cSld>
-  <p:clrMapOvr>
-    <a:masterClrMapping/>
-  </p:clrMapOvr>
-</p:sld>
-</file>
-
-<file path=ppt/slides/slide4.xml><?xml version="1.0" encoding="utf-8"?>
-<p:sld xmlns:a="http://schemas.openxmlformats.org/drawingml/2006/main" xmlns:p="http://schemas.openxmlformats.org/presentationml/2006/main" xmlns:r="http://schemas.openxmlformats.org/officeDocument/2006/relationships">
-  <p:cSld>
-    <p:spTree>
-      <p:nvGrpSpPr>
-        <p:cNvPr id="1" name=""/>
-        <p:cNvGrpSpPr/>
-        <p:nvPr/>
-      </p:nvGrpSpPr>
-      <p:grpSpPr/>
-      <p:sp>
-        <p:nvSpPr>
-          <p:cNvPr id="2" name="TextBox 1"/>
-          <p:cNvSpPr txBox="1"/>
-          <p:nvPr/>
-        </p:nvSpPr>
-        <p:spPr>
-          <a:xfrm>
-            <a:off x="822960" y="548640"/>
-            <a:ext cx="10545775" cy="1097280"/>
-          </a:xfrm>
-          <a:prstGeom prst="rect">
-            <a:avLst/>
-          </a:prstGeom>
-          <a:noFill/>
-        </p:spPr>
-        <p:txBody>
-          <a:bodyPr wrap="square" lIns="0" rIns="0" tIns="0" bIns="0">
-            <a:spAutoFit/>
-          </a:bodyPr>
-          <a:lstStyle/>
-          <a:p>
-            <a:pPr algn="l">
-              <a:lnSpc>
-                <a:spcPct val="100000"/>
-              </a:lnSpc>
-              <a:spcAft>
-                <a:spcPts val="700"/>
-              </a:spcAft>
-            </a:pPr>
-            <a:r>
-              <a:rPr sz="1200" b="1">
-                <a:solidFill>
-                  <a:srgbClr val="1F7A6B"/>
-                </a:solidFill>
-                <a:latin typeface="Calibri"/>
-              </a:rPr>
-              <a:t>RESULT</a:t>
-            </a:r>
-          </a:p>
-          <a:p>
-            <a:pPr algn="l">
-              <a:lnSpc>
-                <a:spcPct val="100000"/>
-              </a:lnSpc>
-              <a:spcAft>
-                <a:spcPts val="0"/>
-              </a:spcAft>
-            </a:pPr>
-            <a:r>
-              <a:rPr sz="3100" b="1">
-                <a:solidFill>
-                  <a:srgbClr val="0B2545"/>
-                </a:solidFill>
-                <a:latin typeface="Calibri"/>
-              </a:rPr>
-              <a:t>Cost against every alternative policy</a:t>
-            </a:r>
-          </a:p>
-        </p:txBody>
-      </p:sp>
-      <p:sp>
-        <p:nvSpPr>
-          <p:cNvPr id="3" name="Rectangle 2"/>
-          <p:cNvSpPr/>
-          <p:nvPr/>
-        </p:nvSpPr>
-        <p:spPr>
-          <a:xfrm>
-            <a:off x="822960" y="1783080"/>
-            <a:ext cx="10545775" cy="15875"/>
-          </a:xfrm>
-          <a:prstGeom prst="rect">
-            <a:avLst/>
-          </a:prstGeom>
-          <a:solidFill>
-            <a:srgbClr val="DDE3E9"/>
-          </a:solidFill>
-          <a:ln>
-            <a:noFill/>
-          </a:ln>
-          <a:effectLst/>
-        </p:spPr>
-        <p:style>
-          <a:lnRef idx="1">
-            <a:schemeClr val="accent1"/>
-          </a:lnRef>
-          <a:fillRef idx="3">
-            <a:schemeClr val="accent1"/>
-          </a:fillRef>
-          <a:effectRef idx="2">
-            <a:schemeClr val="accent1"/>
-          </a:effectRef>
-          <a:fontRef idx="minor">
-            <a:schemeClr val="lt1"/>
-          </a:fontRef>
-        </p:style>
-        <p:txBody>
-          <a:bodyPr rtlCol="0" anchor="ctr"/>
-          <a:lstStyle/>
-          <a:p>
-            <a:pPr algn="ctr"/>
-          </a:p>
-        </p:txBody>
-      </p:sp>
-      <p:sp>
-        <p:nvSpPr>
-          <p:cNvPr id="4" name="TextBox 3"/>
-          <p:cNvSpPr txBox="1"/>
-          <p:nvPr/>
-        </p:nvSpPr>
-        <p:spPr>
-          <a:xfrm>
-            <a:off x="822960" y="6291072"/>
-            <a:ext cx="10545775" cy="274320"/>
-          </a:xfrm>
-          <a:prstGeom prst="rect">
-            <a:avLst/>
-          </a:prstGeom>
-          <a:noFill/>
-        </p:spPr>
-        <p:txBody>
-          <a:bodyPr wrap="square" lIns="0" rIns="0" tIns="0" bIns="0">
-            <a:spAutoFit/>
-          </a:bodyPr>
-          <a:lstStyle/>
-          <a:p>
-            <a:pPr algn="l">
-              <a:lnSpc>
-                <a:spcPct val="100000"/>
-              </a:lnSpc>
-              <a:spcAft>
-                <a:spcPts val="0"/>
-              </a:spcAft>
-            </a:pPr>
-            <a:r>
-              <a:rPr sz="1000" b="0">
-                <a:solidFill>
-                  <a:srgbClr val="8A94A0"/>
-                </a:solidFill>
-                <a:latin typeface="Calibri"/>
-              </a:rPr>
-              <a:t>SCANIA Component X   |   04</a:t>
-            </a:r>
-          </a:p>
-        </p:txBody>
-      </p:sp>
-      <p:sp>
-        <p:nvSpPr>
-          <p:cNvPr id="5" name="Rounded Rectangle 4"/>
-          <p:cNvSpPr/>
-          <p:nvPr/>
-        </p:nvSpPr>
-        <p:spPr>
-          <a:xfrm>
-            <a:off x="822960" y="2057400"/>
-            <a:ext cx="3301898" cy="1508760"/>
-          </a:xfrm>
-          <a:prstGeom prst="roundRect">
-            <a:avLst>
-              <a:gd name="adj" fmla="val 5000"/>
-            </a:avLst>
-          </a:prstGeom>
-          <a:solidFill>
-            <a:srgbClr val="F4F7F9"/>
-          </a:solidFill>
-          <a:ln>
-            <a:noFill/>
-          </a:ln>
-          <a:effectLst/>
-        </p:spPr>
-        <p:style>
-          <a:lnRef idx="1">
-            <a:schemeClr val="accent1"/>
-          </a:lnRef>
-          <a:fillRef idx="3">
-            <a:schemeClr val="accent1"/>
-          </a:fillRef>
-          <a:effectRef idx="2">
-            <a:schemeClr val="accent1"/>
-          </a:effectRef>
-          <a:fontRef idx="minor">
-            <a:schemeClr val="lt1"/>
-          </a:fontRef>
-        </p:style>
-        <p:txBody>
-          <a:bodyPr rtlCol="0" anchor="ctr"/>
-          <a:lstStyle/>
-          <a:p>
-            <a:pPr algn="ctr"/>
-          </a:p>
-        </p:txBody>
-      </p:sp>
-      <p:sp>
-        <p:nvSpPr>
-          <p:cNvPr id="6" name="TextBox 5"/>
-          <p:cNvSpPr txBox="1"/>
-          <p:nvPr/>
-        </p:nvSpPr>
-        <p:spPr>
-          <a:xfrm>
-            <a:off x="1097280" y="2313432"/>
-            <a:ext cx="2753258" cy="1097280"/>
-          </a:xfrm>
-          <a:prstGeom prst="rect">
-            <a:avLst/>
-          </a:prstGeom>
-          <a:noFill/>
-        </p:spPr>
-        <p:txBody>
-          <a:bodyPr wrap="square" lIns="0" rIns="0" tIns="0" bIns="0">
-            <a:spAutoFit/>
-          </a:bodyPr>
-          <a:lstStyle/>
-          <a:p>
-            <a:pPr algn="l">
-              <a:lnSpc>
-                <a:spcPct val="100000"/>
-              </a:lnSpc>
-              <a:spcAft>
-                <a:spcPts val="400"/>
-              </a:spcAft>
-            </a:pPr>
-            <a:r>
-              <a:rPr sz="3400" b="1">
-                <a:solidFill>
-                  <a:srgbClr val="1F7A6B"/>
-                </a:solidFill>
-                <a:latin typeface="Calibri"/>
-              </a:rPr>
-              <a:t>35,469 ± 849</a:t>
-            </a:r>
-          </a:p>
-          <a:p>
-            <a:pPr algn="l">
-              <a:lnSpc>
-                <a:spcPct val="110000"/>
-              </a:lnSpc>
-              <a:spcAft>
-                <a:spcPts val="0"/>
-              </a:spcAft>
-            </a:pPr>
-            <a:r>
-              <a:rPr sz="1200" b="0">
-                <a:solidFill>
-                  <a:srgbClr val="8A94A0"/>
-                </a:solidFill>
-                <a:latin typeface="Calibri"/>
-              </a:rPr>
-              <a:t>Test cost, mean of three seeds</a:t>
-            </a:r>
-          </a:p>
-        </p:txBody>
-      </p:sp>
-      <p:sp>
-        <p:nvSpPr>
-          <p:cNvPr id="7" name="Rounded Rectangle 6"/>
-          <p:cNvSpPr/>
-          <p:nvPr/>
-        </p:nvSpPr>
-        <p:spPr>
-          <a:xfrm>
-            <a:off x="4444898" y="2057400"/>
-            <a:ext cx="3301898" cy="1508760"/>
-          </a:xfrm>
-          <a:prstGeom prst="roundRect">
-            <a:avLst>
-              <a:gd name="adj" fmla="val 5000"/>
-            </a:avLst>
-          </a:prstGeom>
-          <a:solidFill>
-            <a:srgbClr val="F4F7F9"/>
-          </a:solidFill>
-          <a:ln>
-            <a:noFill/>
-          </a:ln>
-          <a:effectLst/>
-        </p:spPr>
-        <p:style>
-          <a:lnRef idx="1">
-            <a:schemeClr val="accent1"/>
-          </a:lnRef>
-          <a:fillRef idx="3">
-            <a:schemeClr val="accent1"/>
-          </a:fillRef>
-          <a:effectRef idx="2">
-            <a:schemeClr val="accent1"/>
-          </a:effectRef>
-          <a:fontRef idx="minor">
-            <a:schemeClr val="lt1"/>
-          </a:fontRef>
-        </p:style>
-        <p:txBody>
-          <a:bodyPr rtlCol="0" anchor="ctr"/>
-          <a:lstStyle/>
-          <a:p>
-            <a:pPr algn="ctr"/>
-          </a:p>
-        </p:txBody>
-      </p:sp>
-      <p:sp>
-        <p:nvSpPr>
-          <p:cNvPr id="8" name="TextBox 7"/>
-          <p:cNvSpPr txBox="1"/>
-          <p:nvPr/>
-        </p:nvSpPr>
-        <p:spPr>
-          <a:xfrm>
-            <a:off x="4719218" y="2313432"/>
-            <a:ext cx="2753258" cy="1097280"/>
-          </a:xfrm>
-          <a:prstGeom prst="rect">
-            <a:avLst/>
-          </a:prstGeom>
-          <a:noFill/>
-        </p:spPr>
-        <p:txBody>
-          <a:bodyPr wrap="square" lIns="0" rIns="0" tIns="0" bIns="0">
-            <a:spAutoFit/>
-          </a:bodyPr>
-          <a:lstStyle/>
-          <a:p>
-            <a:pPr algn="l">
-              <a:lnSpc>
-                <a:spcPct val="100000"/>
-              </a:lnSpc>
-              <a:spcAft>
-                <a:spcPts val="400"/>
-              </a:spcAft>
-            </a:pPr>
-            <a:r>
-              <a:rPr sz="3400" b="1">
-                <a:solidFill>
-                  <a:srgbClr val="0B2545"/>
-                </a:solidFill>
-                <a:latin typeface="Calibri"/>
-              </a:rPr>
-              <a:t>29%</a:t>
-            </a:r>
-          </a:p>
-          <a:p>
-            <a:pPr algn="l">
-              <a:lnSpc>
-                <a:spcPct val="110000"/>
-              </a:lnSpc>
-              <a:spcAft>
-                <a:spcPts val="0"/>
-              </a:spcAft>
-            </a:pPr>
-            <a:r>
-              <a:rPr sz="1200" b="0">
-                <a:solidFill>
-                  <a:srgbClr val="8A94A0"/>
-                </a:solidFill>
-                <a:latin typeface="Calibri"/>
-              </a:rPr>
-              <a:t>Cheaper than checking every truck</a:t>
-            </a:r>
-          </a:p>
-        </p:txBody>
-      </p:sp>
-      <p:sp>
-        <p:nvSpPr>
-          <p:cNvPr id="9" name="Rounded Rectangle 8"/>
-          <p:cNvSpPr/>
-          <p:nvPr/>
-        </p:nvSpPr>
-        <p:spPr>
-          <a:xfrm>
-            <a:off x="8066836" y="2057400"/>
-            <a:ext cx="3301898" cy="1508760"/>
-          </a:xfrm>
-          <a:prstGeom prst="roundRect">
-            <a:avLst>
-              <a:gd name="adj" fmla="val 5000"/>
-            </a:avLst>
-          </a:prstGeom>
-          <a:solidFill>
-            <a:srgbClr val="F4F7F9"/>
-          </a:solidFill>
-          <a:ln>
-            <a:noFill/>
-          </a:ln>
-          <a:effectLst/>
-        </p:spPr>
-        <p:style>
-          <a:lnRef idx="1">
-            <a:schemeClr val="accent1"/>
-          </a:lnRef>
-          <a:fillRef idx="3">
-            <a:schemeClr val="accent1"/>
-          </a:fillRef>
-          <a:effectRef idx="2">
-            <a:schemeClr val="accent1"/>
-          </a:effectRef>
-          <a:fontRef idx="minor">
-            <a:schemeClr val="lt1"/>
-          </a:fontRef>
-        </p:style>
-        <p:txBody>
-          <a:bodyPr rtlCol="0" anchor="ctr"/>
-          <a:lstStyle/>
-          <a:p>
-            <a:pPr algn="ctr"/>
-          </a:p>
-        </p:txBody>
-      </p:sp>
-      <p:sp>
-        <p:nvSpPr>
-          <p:cNvPr id="10" name="TextBox 9"/>
-          <p:cNvSpPr txBox="1"/>
-          <p:nvPr/>
-        </p:nvSpPr>
-        <p:spPr>
-          <a:xfrm>
-            <a:off x="8341156" y="2313432"/>
-            <a:ext cx="2753258" cy="1097280"/>
-          </a:xfrm>
-          <a:prstGeom prst="rect">
-            <a:avLst/>
-          </a:prstGeom>
-          <a:noFill/>
-        </p:spPr>
-        <p:txBody>
-          <a:bodyPr wrap="square" lIns="0" rIns="0" tIns="0" bIns="0">
+          <a:bodyPr wrap="square" lIns="0" tIns="0" rIns="0" bIns="0">
             <a:spAutoFit/>
           </a:bodyPr>
           <a:lstStyle/>
@@ -5628,7 +5300,13 @@
           <p:cNvGraphicFramePr>
             <a:graphicFrameLocks noGrp="1"/>
           </p:cNvGraphicFramePr>
-          <p:nvPr/>
+          <p:nvPr>
+            <p:extLst>
+              <p:ext uri="{D42A27DB-BD31-4B8C-83A1-F6EECF244321}">
+                <p14:modId xmlns:p14="http://schemas.microsoft.com/office/powerpoint/2010/main" val="2141266766"/>
+              </p:ext>
+            </p:extLst>
+          </p:nvPr>
         </p:nvGraphicFramePr>
         <p:xfrm>
           <a:off x="822960" y="3931919"/>
@@ -5641,13 +5319,25 @@
                 <a:tableStyleId>{5C22544A-7EE6-4342-B048-85BDC9FD1C3A}</a:tableStyleId>
               </a:tblPr>
               <a:tblGrid>
-                <a:gridCol w="7592958"/>
-                <a:gridCol w="2952817"/>
+                <a:gridCol w="7592958">
+                  <a:extLst>
+                    <a:ext uri="{9D8B030D-6E8A-4147-A177-3AD203B41FA5}">
+                      <a16:colId xmlns:a16="http://schemas.microsoft.com/office/drawing/2014/main" val="20000"/>
+                    </a:ext>
+                  </a:extLst>
+                </a:gridCol>
+                <a:gridCol w="2952817">
+                  <a:extLst>
+                    <a:ext uri="{9D8B030D-6E8A-4147-A177-3AD203B41FA5}">
+                      <a16:colId xmlns:a16="http://schemas.microsoft.com/office/drawing/2014/main" val="20001"/>
+                    </a:ext>
+                  </a:extLst>
+                </a:gridCol>
               </a:tblGrid>
               <a:tr h="420624">
                 <a:tc>
                   <a:txBody>
-                    <a:bodyPr wrap="square"/>
+                    <a:bodyPr/>
                     <a:lstStyle/>
                     <a:p>
                       <a:pPr algn="l">
@@ -5677,7 +5367,7 @@
                 </a:tc>
                 <a:tc>
                   <a:txBody>
-                    <a:bodyPr wrap="square"/>
+                    <a:bodyPr/>
                     <a:lstStyle/>
                     <a:p>
                       <a:pPr algn="r">
@@ -5705,11 +5395,16 @@
                     </a:solidFill>
                   </a:tcPr>
                 </a:tc>
+                <a:extLst>
+                  <a:ext uri="{0D108BD9-81ED-4DB2-BD59-A6C34878D82A}">
+                    <a16:rowId xmlns:a16="http://schemas.microsoft.com/office/drawing/2014/main" val="10000"/>
+                  </a:ext>
+                </a:extLst>
               </a:tr>
               <a:tr h="420624">
                 <a:tc>
                   <a:txBody>
-                    <a:bodyPr wrap="square"/>
+                    <a:bodyPr/>
                     <a:lstStyle/>
                     <a:p>
                       <a:pPr algn="l">
@@ -5721,14 +5416,20 @@
                         </a:spcAft>
                       </a:pPr>
                       <a:r>
-                        <a:rPr sz="1500" b="1">
+                        <a:rPr lang="en-US" sz="1500" b="1" dirty="0">
                           <a:solidFill>
                             <a:srgbClr val="1F7A6B"/>
                           </a:solidFill>
                           <a:latin typeface="Calibri"/>
                         </a:rPr>
-                        <a:t>AutoGluon LightGBM, cost-optimal rule (3 seeds)</a:t>
+                        <a:t>Our Solution ( Optimize Machine learning sample test set with 3 seeds )</a:t>
                       </a:r>
+                      <a:endParaRPr sz="1500" b="1" dirty="0">
+                        <a:solidFill>
+                          <a:srgbClr val="1F7A6B"/>
+                        </a:solidFill>
+                        <a:latin typeface="Calibri"/>
+                      </a:endParaRPr>
                     </a:p>
                   </a:txBody>
                   <a:tcPr marL="128016" marR="128016">
@@ -5739,7 +5440,7 @@
                 </a:tc>
                 <a:tc>
                   <a:txBody>
-                    <a:bodyPr wrap="square"/>
+                    <a:bodyPr/>
                     <a:lstStyle/>
                     <a:p>
                       <a:pPr algn="r">
@@ -5767,11 +5468,16 @@
                     </a:solidFill>
                   </a:tcPr>
                 </a:tc>
+                <a:extLst>
+                  <a:ext uri="{0D108BD9-81ED-4DB2-BD59-A6C34878D82A}">
+                    <a16:rowId xmlns:a16="http://schemas.microsoft.com/office/drawing/2014/main" val="10001"/>
+                  </a:ext>
+                </a:extLst>
               </a:tr>
               <a:tr h="420624">
                 <a:tc>
                   <a:txBody>
-                    <a:bodyPr wrap="square"/>
+                    <a:bodyPr/>
                     <a:lstStyle/>
                     <a:p>
                       <a:pPr algn="l">
@@ -5801,7 +5507,7 @@
                 </a:tc>
                 <a:tc>
                   <a:txBody>
-                    <a:bodyPr wrap="square"/>
+                    <a:bodyPr/>
                     <a:lstStyle/>
                     <a:p>
                       <a:pPr algn="r">
@@ -5829,11 +5535,16 @@
                     </a:solidFill>
                   </a:tcPr>
                 </a:tc>
+                <a:extLst>
+                  <a:ext uri="{0D108BD9-81ED-4DB2-BD59-A6C34878D82A}">
+                    <a16:rowId xmlns:a16="http://schemas.microsoft.com/office/drawing/2014/main" val="10002"/>
+                  </a:ext>
+                </a:extLst>
               </a:tr>
               <a:tr h="420624">
                 <a:tc>
                   <a:txBody>
-                    <a:bodyPr wrap="square"/>
+                    <a:bodyPr/>
                     <a:lstStyle/>
                     <a:p>
                       <a:pPr algn="l">
@@ -5863,7 +5574,7 @@
                 </a:tc>
                 <a:tc>
                   <a:txBody>
-                    <a:bodyPr wrap="square"/>
+                    <a:bodyPr/>
                     <a:lstStyle/>
                     <a:p>
                       <a:pPr algn="r">
@@ -5891,11 +5602,16 @@
                     </a:solidFill>
                   </a:tcPr>
                 </a:tc>
+                <a:extLst>
+                  <a:ext uri="{0D108BD9-81ED-4DB2-BD59-A6C34878D82A}">
+                    <a16:rowId xmlns:a16="http://schemas.microsoft.com/office/drawing/2014/main" val="10003"/>
+                  </a:ext>
+                </a:extLst>
               </a:tr>
               <a:tr h="420624">
                 <a:tc>
                   <a:txBody>
-                    <a:bodyPr wrap="square"/>
+                    <a:bodyPr/>
                     <a:lstStyle/>
                     <a:p>
                       <a:pPr algn="l">
@@ -5925,7 +5641,7 @@
                 </a:tc>
                 <a:tc>
                   <a:txBody>
-                    <a:bodyPr wrap="square"/>
+                    <a:bodyPr/>
                     <a:lstStyle/>
                     <a:p>
                       <a:pPr algn="r">
@@ -5937,7 +5653,7 @@
                         </a:spcAft>
                       </a:pPr>
                       <a:r>
-                        <a:rPr sz="1500" b="0">
+                        <a:rPr sz="1500" b="0" dirty="0">
                           <a:solidFill>
                             <a:srgbClr val="343D4A"/>
                           </a:solidFill>
@@ -5953,6 +5669,11 @@
                     </a:solidFill>
                   </a:tcPr>
                 </a:tc>
+                <a:extLst>
+                  <a:ext uri="{0D108BD9-81ED-4DB2-BD59-A6C34878D82A}">
+                    <a16:rowId xmlns:a16="http://schemas.microsoft.com/office/drawing/2014/main" val="10004"/>
+                  </a:ext>
+                </a:extLst>
               </a:tr>
             </a:tbl>
           </a:graphicData>
@@ -5967,7 +5688,7 @@
 </file>
 
 <file path=ppt/slides/slide5.xml><?xml version="1.0" encoding="utf-8"?>
-<p:sld xmlns:a="http://schemas.openxmlformats.org/drawingml/2006/main" xmlns:p="http://schemas.openxmlformats.org/presentationml/2006/main" xmlns:r="http://schemas.openxmlformats.org/officeDocument/2006/relationships">
+<p:sld xmlns:a="http://schemas.openxmlformats.org/drawingml/2006/main" xmlns:r="http://schemas.openxmlformats.org/officeDocument/2006/relationships" xmlns:p="http://schemas.openxmlformats.org/presentationml/2006/main">
   <p:cSld>
     <p:spTree>
       <p:nvGrpSpPr>
@@ -5975,7 +5696,14 @@
         <p:cNvGrpSpPr/>
         <p:nvPr/>
       </p:nvGrpSpPr>
-      <p:grpSpPr/>
+      <p:grpSpPr>
+        <a:xfrm>
+          <a:off x="0" y="0"/>
+          <a:ext cx="0" cy="0"/>
+          <a:chOff x="0" y="0"/>
+          <a:chExt cx="0" cy="0"/>
+        </a:xfrm>
+      </p:grpSpPr>
       <p:sp>
         <p:nvSpPr>
           <p:cNvPr id="2" name="TextBox 1"/>
@@ -5993,7 +5721,7 @@
           <a:noFill/>
         </p:spPr>
         <p:txBody>
-          <a:bodyPr wrap="square" lIns="0" rIns="0" tIns="0" bIns="0">
+          <a:bodyPr wrap="square" lIns="0" tIns="0" rIns="0" bIns="0">
             <a:spAutoFit/>
           </a:bodyPr>
           <a:lstStyle/>
@@ -6078,6 +5806,7 @@
           <a:lstStyle/>
           <a:p>
             <a:pPr algn="ctr"/>
+            <a:endParaRPr/>
           </a:p>
         </p:txBody>
       </p:sp>
@@ -6098,7 +5827,7 @@
           <a:noFill/>
         </p:spPr>
         <p:txBody>
-          <a:bodyPr wrap="square" lIns="0" rIns="0" tIns="0" bIns="0">
+          <a:bodyPr wrap="square" lIns="0" tIns="0" rIns="0" bIns="0">
             <a:spAutoFit/>
           </a:bodyPr>
           <a:lstStyle/>
@@ -6132,7 +5861,7 @@
         <p:spPr>
           <a:xfrm>
             <a:off x="822960" y="2057400"/>
-            <a:ext cx="10545775" cy="3886200"/>
+            <a:ext cx="10545775" cy="1654556"/>
           </a:xfrm>
           <a:prstGeom prst="rect">
             <a:avLst/>
@@ -6140,7 +5869,7 @@
           <a:noFill/>
         </p:spPr>
         <p:txBody>
-          <a:bodyPr wrap="square" lIns="0" rIns="0" tIns="0" bIns="0">
+          <a:bodyPr wrap="square" lIns="0" tIns="0" rIns="0" bIns="0">
             <a:spAutoFit/>
           </a:bodyPr>
           <a:lstStyle/>
@@ -6154,7 +5883,7 @@
               </a:spcAft>
             </a:pPr>
             <a:r>
-              <a:rPr sz="1600" b="1">
+              <a:rPr sz="1600" b="1" dirty="0">
                 <a:solidFill>
                   <a:srgbClr val="0B2545"/>
                 </a:solidFill>
@@ -6163,13 +5892,13 @@
               <a:t>109 of 142 at-risk trucks are caught</a:t>
             </a:r>
             <a:r>
-              <a:rPr sz="1600">
+              <a:rPr sz="1600" dirty="0">
                 <a:solidFill>
                   <a:srgbClr val="343D4A"/>
                 </a:solidFill>
                 <a:latin typeface="Calibri"/>
               </a:rPr>
-              <a:t>  before the component fails, at the tuned operating point.</a:t>
+              <a:t>  before the component fails at the tuned operating point.</a:t>
             </a:r>
           </a:p>
           <a:p>
@@ -6182,7 +5911,7 @@
               </a:spcAft>
             </a:pPr>
             <a:r>
-              <a:rPr sz="1600" b="1">
+              <a:rPr sz="1600" b="1" dirty="0">
                 <a:solidFill>
                   <a:srgbClr val="0B2545"/>
                 </a:solidFill>
@@ -6191,7 +5920,7 @@
               <a:t>About 2,100 of 5,045 trucks are called in.</a:t>
             </a:r>
             <a:r>
-              <a:rPr sz="1600">
+              <a:rPr sz="1600" dirty="0">
                 <a:solidFill>
                   <a:srgbClr val="343D4A"/>
                 </a:solidFill>
@@ -6210,22 +5939,22 @@
               </a:spcAft>
             </a:pPr>
             <a:r>
-              <a:rPr sz="1600" b="1">
+              <a:rPr sz="1600" b="1" dirty="0">
                 <a:solidFill>
                   <a:srgbClr val="0B2545"/>
                 </a:solidFill>
                 <a:latin typeface="Calibri"/>
               </a:rPr>
-              <a:t>The saving comes from not inspecting the other 2,900,</a:t>
-            </a:r>
-            <a:r>
-              <a:rPr sz="1600">
+              <a:t>The saving comes from not inspecting the other 2,900</a:t>
+            </a:r>
+            <a:r>
+              <a:rPr sz="1600" dirty="0">
                 <a:solidFill>
                   <a:srgbClr val="343D4A"/>
                 </a:solidFill>
                 <a:latin typeface="Calibri"/>
               </a:rPr>
-              <a:t>  while still reaching most of the trucks that were going to fail.</a:t>
+              <a:t> while still reaching most of the trucks that were going to fail.</a:t>
             </a:r>
           </a:p>
           <a:p>
@@ -6238,7 +5967,7 @@
               </a:spcAft>
             </a:pPr>
             <a:r>
-              <a:rPr sz="1600" b="1">
+              <a:rPr sz="1600" b="1" dirty="0">
                 <a:solidFill>
                   <a:srgbClr val="0B2545"/>
                 </a:solidFill>
@@ -6247,13 +5976,13 @@
               <a:t>33 at-risk trucks are still missed.</a:t>
             </a:r>
             <a:r>
-              <a:rPr sz="1600">
+              <a:rPr sz="1600" dirty="0">
                 <a:solidFill>
                   <a:srgbClr val="343D4A"/>
                 </a:solidFill>
                 <a:latin typeface="Calibri"/>
               </a:rPr>
-              <a:t>  That residual is the honest cost of the current model, and it is where further work pays.</a:t>
+              <a:t>  That residual is the honest cost of the current model and it is where further work pays.</a:t>
             </a:r>
           </a:p>
         </p:txBody>
@@ -6267,7 +5996,7 @@
 </file>
 
 <file path=ppt/slides/slide6.xml><?xml version="1.0" encoding="utf-8"?>
-<p:sld xmlns:a="http://schemas.openxmlformats.org/drawingml/2006/main" xmlns:p="http://schemas.openxmlformats.org/presentationml/2006/main" xmlns:r="http://schemas.openxmlformats.org/officeDocument/2006/relationships">
+<p:sld xmlns:a="http://schemas.openxmlformats.org/drawingml/2006/main" xmlns:r="http://schemas.openxmlformats.org/officeDocument/2006/relationships" xmlns:p="http://schemas.openxmlformats.org/presentationml/2006/main">
   <p:cSld>
     <p:spTree>
       <p:nvGrpSpPr>
@@ -6275,7 +6004,14 @@
         <p:cNvGrpSpPr/>
         <p:nvPr/>
       </p:nvGrpSpPr>
-      <p:grpSpPr/>
+      <p:grpSpPr>
+        <a:xfrm>
+          <a:off x="0" y="0"/>
+          <a:ext cx="0" cy="0"/>
+          <a:chOff x="0" y="0"/>
+          <a:chExt cx="0" cy="0"/>
+        </a:xfrm>
+      </p:grpSpPr>
       <p:sp>
         <p:nvSpPr>
           <p:cNvPr id="2" name="TextBox 1"/>
@@ -6293,7 +6029,7 @@
           <a:noFill/>
         </p:spPr>
         <p:txBody>
-          <a:bodyPr wrap="square" lIns="0" rIns="0" tIns="0" bIns="0">
+          <a:bodyPr wrap="square" lIns="0" tIns="0" rIns="0" bIns="0">
             <a:spAutoFit/>
           </a:bodyPr>
           <a:lstStyle/>
@@ -6307,7 +6043,7 @@
               </a:spcAft>
             </a:pPr>
             <a:r>
-              <a:rPr sz="1200" b="1">
+              <a:rPr sz="1200" b="1" dirty="0">
                 <a:solidFill>
                   <a:srgbClr val="1F7A6B"/>
                 </a:solidFill>
@@ -6315,6 +6051,12 @@
               </a:rPr>
               <a:t>BENCHMARK</a:t>
             </a:r>
+            <a:endParaRPr lang="en-US" sz="1200" b="1" dirty="0">
+              <a:solidFill>
+                <a:srgbClr val="1F7A6B"/>
+              </a:solidFill>
+              <a:latin typeface="Calibri"/>
+            </a:endParaRPr>
           </a:p>
           <a:p>
             <a:pPr algn="l">
@@ -6326,7 +6068,7 @@
               </a:spcAft>
             </a:pPr>
             <a:r>
-              <a:rPr sz="3100" b="1">
+              <a:rPr lang="en-US" sz="3100" b="1" dirty="0">
                 <a:solidFill>
                   <a:srgbClr val="0B2545"/>
                 </a:solidFill>
@@ -6378,6 +6120,7 @@
           <a:lstStyle/>
           <a:p>
             <a:pPr algn="ctr"/>
+            <a:endParaRPr/>
           </a:p>
         </p:txBody>
       </p:sp>
@@ -6398,7 +6141,7 @@
           <a:noFill/>
         </p:spPr>
         <p:txBody>
-          <a:bodyPr wrap="square" lIns="0" rIns="0" tIns="0" bIns="0">
+          <a:bodyPr wrap="square" lIns="0" tIns="0" rIns="0" bIns="0">
             <a:spAutoFit/>
           </a:bodyPr>
           <a:lstStyle/>
@@ -6429,7 +6172,13 @@
           <p:cNvGraphicFramePr>
             <a:graphicFrameLocks noGrp="1"/>
           </p:cNvGraphicFramePr>
-          <p:nvPr/>
+          <p:nvPr>
+            <p:extLst>
+              <p:ext uri="{D42A27DB-BD31-4B8C-83A1-F6EECF244321}">
+                <p14:modId xmlns:p14="http://schemas.microsoft.com/office/powerpoint/2010/main" val="1438950894"/>
+              </p:ext>
+            </p:extLst>
+          </p:nvPr>
         </p:nvGraphicFramePr>
         <p:xfrm>
           <a:off x="822960" y="2057400"/>
@@ -6442,13 +6191,25 @@
                 <a:tableStyleId>{5C22544A-7EE6-4342-B048-85BDC9FD1C3A}</a:tableStyleId>
               </a:tblPr>
               <a:tblGrid>
-                <a:gridCol w="7592958"/>
-                <a:gridCol w="2952817"/>
+                <a:gridCol w="7592958">
+                  <a:extLst>
+                    <a:ext uri="{9D8B030D-6E8A-4147-A177-3AD203B41FA5}">
+                      <a16:colId xmlns:a16="http://schemas.microsoft.com/office/drawing/2014/main" val="20000"/>
+                    </a:ext>
+                  </a:extLst>
+                </a:gridCol>
+                <a:gridCol w="2952817">
+                  <a:extLst>
+                    <a:ext uri="{9D8B030D-6E8A-4147-A177-3AD203B41FA5}">
+                      <a16:colId xmlns:a16="http://schemas.microsoft.com/office/drawing/2014/main" val="20001"/>
+                    </a:ext>
+                  </a:extLst>
+                </a:gridCol>
               </a:tblGrid>
               <a:tr h="420624">
                 <a:tc>
                   <a:txBody>
-                    <a:bodyPr wrap="square"/>
+                    <a:bodyPr/>
                     <a:lstStyle/>
                     <a:p>
                       <a:pPr algn="l">
@@ -6478,7 +6239,7 @@
                 </a:tc>
                 <a:tc>
                   <a:txBody>
-                    <a:bodyPr wrap="square"/>
+                    <a:bodyPr/>
                     <a:lstStyle/>
                     <a:p>
                       <a:pPr algn="r">
@@ -6506,11 +6267,16 @@
                     </a:solidFill>
                   </a:tcPr>
                 </a:tc>
+                <a:extLst>
+                  <a:ext uri="{0D108BD9-81ED-4DB2-BD59-A6C34878D82A}">
+                    <a16:rowId xmlns:a16="http://schemas.microsoft.com/office/drawing/2014/main" val="10000"/>
+                  </a:ext>
+                </a:extLst>
               </a:tr>
               <a:tr h="420624">
                 <a:tc>
                   <a:txBody>
-                    <a:bodyPr wrap="square"/>
+                    <a:bodyPr/>
                     <a:lstStyle/>
                     <a:p>
                       <a:pPr algn="l">
@@ -6522,14 +6288,20 @@
                         </a:spcAft>
                       </a:pPr>
                       <a:r>
-                        <a:rPr sz="1500" b="1">
+                        <a:rPr lang="en-US" sz="1500" b="1" dirty="0">
                           <a:solidFill>
                             <a:srgbClr val="1F7A6B"/>
                           </a:solidFill>
                           <a:latin typeface="Calibri"/>
                         </a:rPr>
-                        <a:t>This work, AutoGluon LightGBM (3 seeds)</a:t>
+                        <a:t>Our work</a:t>
                       </a:r>
+                      <a:endParaRPr sz="1500" b="1" dirty="0">
+                        <a:solidFill>
+                          <a:srgbClr val="1F7A6B"/>
+                        </a:solidFill>
+                        <a:latin typeface="Calibri"/>
+                      </a:endParaRPr>
                     </a:p>
                   </a:txBody>
                   <a:tcPr marL="128016" marR="128016">
@@ -6540,7 +6312,7 @@
                 </a:tc>
                 <a:tc>
                   <a:txBody>
-                    <a:bodyPr wrap="square"/>
+                    <a:bodyPr/>
                     <a:lstStyle/>
                     <a:p>
                       <a:pPr algn="r">
@@ -6568,11 +6340,16 @@
                     </a:solidFill>
                   </a:tcPr>
                 </a:tc>
+                <a:extLst>
+                  <a:ext uri="{0D108BD9-81ED-4DB2-BD59-A6C34878D82A}">
+                    <a16:rowId xmlns:a16="http://schemas.microsoft.com/office/drawing/2014/main" val="10001"/>
+                  </a:ext>
+                </a:extLst>
               </a:tr>
               <a:tr h="420624">
                 <a:tc>
                   <a:txBody>
-                    <a:bodyPr wrap="square"/>
+                    <a:bodyPr/>
                     <a:lstStyle/>
                     <a:p>
                       <a:pPr algn="l">
@@ -6584,13 +6361,31 @@
                         </a:spcAft>
                       </a:pPr>
                       <a:r>
-                        <a:rPr sz="1500" b="0">
+                        <a:rPr sz="1500" b="0" dirty="0">
                           <a:solidFill>
                             <a:srgbClr val="343D4A"/>
                           </a:solidFill>
                           <a:latin typeface="Calibri"/>
                         </a:rPr>
-                        <a:t>Published CatBoost result on the same benchmark</a:t>
+                        <a:t>Published </a:t>
+                      </a:r>
+                      <a:r>
+                        <a:rPr sz="1500" b="0" dirty="0" err="1">
+                          <a:solidFill>
+                            <a:srgbClr val="343D4A"/>
+                          </a:solidFill>
+                          <a:latin typeface="Calibri"/>
+                        </a:rPr>
+                        <a:t>CatBoost</a:t>
+                      </a:r>
+                      <a:r>
+                        <a:rPr sz="1500" b="0" dirty="0">
+                          <a:solidFill>
+                            <a:srgbClr val="343D4A"/>
+                          </a:solidFill>
+                          <a:latin typeface="Calibri"/>
+                        </a:rPr>
+                        <a:t> result on the same benchmark</a:t>
                       </a:r>
                     </a:p>
                   </a:txBody>
@@ -6602,7 +6397,7 @@
                 </a:tc>
                 <a:tc>
                   <a:txBody>
-                    <a:bodyPr wrap="square"/>
+                    <a:bodyPr/>
                     <a:lstStyle/>
                     <a:p>
                       <a:pPr algn="r">
@@ -6630,11 +6425,16 @@
                     </a:solidFill>
                   </a:tcPr>
                 </a:tc>
+                <a:extLst>
+                  <a:ext uri="{0D108BD9-81ED-4DB2-BD59-A6C34878D82A}">
+                    <a16:rowId xmlns:a16="http://schemas.microsoft.com/office/drawing/2014/main" val="10002"/>
+                  </a:ext>
+                </a:extLst>
               </a:tr>
               <a:tr h="420624">
                 <a:tc>
                   <a:txBody>
-                    <a:bodyPr wrap="square"/>
+                    <a:bodyPr/>
                     <a:lstStyle/>
                     <a:p>
                       <a:pPr algn="l">
@@ -6646,7 +6446,7 @@
                         </a:spcAft>
                       </a:pPr>
                       <a:r>
-                        <a:rPr sz="1500" b="0">
+                        <a:rPr sz="1500" b="0" dirty="0">
                           <a:solidFill>
                             <a:srgbClr val="343D4A"/>
                           </a:solidFill>
@@ -6664,7 +6464,7 @@
                 </a:tc>
                 <a:tc>
                   <a:txBody>
-                    <a:bodyPr wrap="square"/>
+                    <a:bodyPr/>
                     <a:lstStyle/>
                     <a:p>
                       <a:pPr algn="r">
@@ -6676,7 +6476,7 @@
                         </a:spcAft>
                       </a:pPr>
                       <a:r>
-                        <a:rPr sz="1500" b="0">
+                        <a:rPr sz="1500" b="0" dirty="0">
                           <a:solidFill>
                             <a:srgbClr val="343D4A"/>
                           </a:solidFill>
@@ -6692,6 +6492,11 @@
                     </a:solidFill>
                   </a:tcPr>
                 </a:tc>
+                <a:extLst>
+                  <a:ext uri="{0D108BD9-81ED-4DB2-BD59-A6C34878D82A}">
+                    <a16:rowId xmlns:a16="http://schemas.microsoft.com/office/drawing/2014/main" val="10003"/>
+                  </a:ext>
+                </a:extLst>
               </a:tr>
             </a:tbl>
           </a:graphicData>
@@ -6714,7 +6519,7 @@
           <a:noFill/>
         </p:spPr>
         <p:txBody>
-          <a:bodyPr wrap="square" lIns="0" rIns="0" tIns="0" bIns="0">
+          <a:bodyPr wrap="square" lIns="0" tIns="0" rIns="0" bIns="0">
             <a:spAutoFit/>
           </a:bodyPr>
           <a:lstStyle/>
@@ -6776,7 +6581,7 @@
 </file>
 
 <file path=ppt/slides/slide7.xml><?xml version="1.0" encoding="utf-8"?>
-<p:sld xmlns:a="http://schemas.openxmlformats.org/drawingml/2006/main" xmlns:p="http://schemas.openxmlformats.org/presentationml/2006/main" xmlns:r="http://schemas.openxmlformats.org/officeDocument/2006/relationships">
+<p:sld xmlns:a="http://schemas.openxmlformats.org/drawingml/2006/main" xmlns:r="http://schemas.openxmlformats.org/officeDocument/2006/relationships" xmlns:p="http://schemas.openxmlformats.org/presentationml/2006/main">
   <p:cSld>
     <p:spTree>
       <p:nvGrpSpPr>
@@ -6784,7 +6589,14 @@
         <p:cNvGrpSpPr/>
         <p:nvPr/>
       </p:nvGrpSpPr>
-      <p:grpSpPr/>
+      <p:grpSpPr>
+        <a:xfrm>
+          <a:off x="0" y="0"/>
+          <a:ext cx="0" cy="0"/>
+          <a:chOff x="0" y="0"/>
+          <a:chExt cx="0" cy="0"/>
+        </a:xfrm>
+      </p:grpSpPr>
       <p:sp>
         <p:nvSpPr>
           <p:cNvPr id="2" name="TextBox 1"/>
@@ -6802,7 +6614,7 @@
           <a:noFill/>
         </p:spPr>
         <p:txBody>
-          <a:bodyPr wrap="square" lIns="0" rIns="0" tIns="0" bIns="0">
+          <a:bodyPr wrap="square" lIns="0" tIns="0" rIns="0" bIns="0">
             <a:spAutoFit/>
           </a:bodyPr>
           <a:lstStyle/>
@@ -6887,6 +6699,7 @@
           <a:lstStyle/>
           <a:p>
             <a:pPr algn="ctr"/>
+            <a:endParaRPr/>
           </a:p>
         </p:txBody>
       </p:sp>
@@ -6907,7 +6720,7 @@
           <a:noFill/>
         </p:spPr>
         <p:txBody>
-          <a:bodyPr wrap="square" lIns="0" rIns="0" tIns="0" bIns="0">
+          <a:bodyPr wrap="square" lIns="0" tIns="0" rIns="0" bIns="0">
             <a:spAutoFit/>
           </a:bodyPr>
           <a:lstStyle/>
@@ -6949,7 +6762,7 @@
           <a:noFill/>
         </p:spPr>
         <p:txBody>
-          <a:bodyPr wrap="square" lIns="0" rIns="0" tIns="0" bIns="0">
+          <a:bodyPr wrap="square" lIns="0" tIns="0" rIns="0" bIns="0">
             <a:spAutoFit/>
           </a:bodyPr>
           <a:lstStyle/>
@@ -7076,7 +6889,7 @@
 </file>
 
 <file path=ppt/slides/slide8.xml><?xml version="1.0" encoding="utf-8"?>
-<p:sld xmlns:a="http://schemas.openxmlformats.org/drawingml/2006/main" xmlns:p="http://schemas.openxmlformats.org/presentationml/2006/main" xmlns:r="http://schemas.openxmlformats.org/officeDocument/2006/relationships">
+<p:sld xmlns:a="http://schemas.openxmlformats.org/drawingml/2006/main" xmlns:r="http://schemas.openxmlformats.org/officeDocument/2006/relationships" xmlns:p="http://schemas.openxmlformats.org/presentationml/2006/main">
   <p:cSld>
     <p:spTree>
       <p:nvGrpSpPr>
@@ -7084,7 +6897,14 @@
         <p:cNvGrpSpPr/>
         <p:nvPr/>
       </p:nvGrpSpPr>
-      <p:grpSpPr/>
+      <p:grpSpPr>
+        <a:xfrm>
+          <a:off x="0" y="0"/>
+          <a:ext cx="0" cy="0"/>
+          <a:chOff x="0" y="0"/>
+          <a:chExt cx="0" cy="0"/>
+        </a:xfrm>
+      </p:grpSpPr>
       <p:sp>
         <p:nvSpPr>
           <p:cNvPr id="2" name="TextBox 1"/>
@@ -7102,7 +6922,7 @@
           <a:noFill/>
         </p:spPr>
         <p:txBody>
-          <a:bodyPr wrap="square" lIns="0" rIns="0" tIns="0" bIns="0">
+          <a:bodyPr wrap="square" lIns="0" tIns="0" rIns="0" bIns="0">
             <a:spAutoFit/>
           </a:bodyPr>
           <a:lstStyle/>
@@ -7187,6 +7007,7 @@
           <a:lstStyle/>
           <a:p>
             <a:pPr algn="ctr"/>
+            <a:endParaRPr/>
           </a:p>
         </p:txBody>
       </p:sp>
@@ -7207,7 +7028,7 @@
           <a:noFill/>
         </p:spPr>
         <p:txBody>
-          <a:bodyPr wrap="square" lIns="0" rIns="0" tIns="0" bIns="0">
+          <a:bodyPr wrap="square" lIns="0" tIns="0" rIns="0" bIns="0">
             <a:spAutoFit/>
           </a:bodyPr>
           <a:lstStyle/>
@@ -7275,6 +7096,7 @@
           <a:lstStyle/>
           <a:p>
             <a:pPr algn="ctr"/>
+            <a:endParaRPr/>
           </a:p>
         </p:txBody>
       </p:sp>
@@ -7295,7 +7117,7 @@
           <a:noFill/>
         </p:spPr>
         <p:txBody>
-          <a:bodyPr wrap="square" lIns="0" rIns="0" tIns="0" bIns="0">
+          <a:bodyPr wrap="square" lIns="0" tIns="0" rIns="0" bIns="0">
             <a:spAutoFit/>
           </a:bodyPr>
           <a:lstStyle/>
@@ -7382,6 +7204,7 @@
           <a:lstStyle/>
           <a:p>
             <a:pPr algn="ctr"/>
+            <a:endParaRPr/>
           </a:p>
         </p:txBody>
       </p:sp>
@@ -7402,7 +7225,7 @@
           <a:noFill/>
         </p:spPr>
         <p:txBody>
-          <a:bodyPr wrap="square" lIns="0" rIns="0" tIns="0" bIns="0">
+          <a:bodyPr wrap="square" lIns="0" tIns="0" rIns="0" bIns="0">
             <a:spAutoFit/>
           </a:bodyPr>
           <a:lstStyle/>
@@ -7489,6 +7312,7 @@
           <a:lstStyle/>
           <a:p>
             <a:pPr algn="ctr"/>
+            <a:endParaRPr/>
           </a:p>
         </p:txBody>
       </p:sp>
@@ -7509,7 +7333,7 @@
           <a:noFill/>
         </p:spPr>
         <p:txBody>
-          <a:bodyPr wrap="square" lIns="0" rIns="0" tIns="0" bIns="0">
+          <a:bodyPr wrap="square" lIns="0" tIns="0" rIns="0" bIns="0">
             <a:spAutoFit/>
           </a:bodyPr>
           <a:lstStyle/>
@@ -7570,7 +7394,7 @@
           <a:noFill/>
         </p:spPr>
         <p:txBody>
-          <a:bodyPr wrap="square" lIns="0" rIns="0" tIns="0" bIns="0">
+          <a:bodyPr wrap="square" lIns="0" tIns="0" rIns="0" bIns="0">
             <a:spAutoFit/>
           </a:bodyPr>
           <a:lstStyle/>
@@ -7660,7 +7484,7 @@
 </file>
 
 <file path=ppt/slides/slide9.xml><?xml version="1.0" encoding="utf-8"?>
-<p:sld xmlns:a="http://schemas.openxmlformats.org/drawingml/2006/main" xmlns:p="http://schemas.openxmlformats.org/presentationml/2006/main" xmlns:r="http://schemas.openxmlformats.org/officeDocument/2006/relationships">
+<p:sld xmlns:a="http://schemas.openxmlformats.org/drawingml/2006/main" xmlns:r="http://schemas.openxmlformats.org/officeDocument/2006/relationships" xmlns:p="http://schemas.openxmlformats.org/presentationml/2006/main">
   <p:cSld>
     <p:spTree>
       <p:nvGrpSpPr>
@@ -7668,7 +7492,14 @@
         <p:cNvGrpSpPr/>
         <p:nvPr/>
       </p:nvGrpSpPr>
-      <p:grpSpPr/>
+      <p:grpSpPr>
+        <a:xfrm>
+          <a:off x="0" y="0"/>
+          <a:ext cx="0" cy="0"/>
+          <a:chOff x="0" y="0"/>
+          <a:chExt cx="0" cy="0"/>
+        </a:xfrm>
+      </p:grpSpPr>
       <p:sp>
         <p:nvSpPr>
           <p:cNvPr id="2" name="TextBox 1"/>
@@ -7686,7 +7517,7 @@
           <a:noFill/>
         </p:spPr>
         <p:txBody>
-          <a:bodyPr wrap="square" lIns="0" rIns="0" tIns="0" bIns="0">
+          <a:bodyPr wrap="square" lIns="0" tIns="0" rIns="0" bIns="0">
             <a:spAutoFit/>
           </a:bodyPr>
           <a:lstStyle/>
@@ -7771,6 +7602,7 @@
           <a:lstStyle/>
           <a:p>
             <a:pPr algn="ctr"/>
+            <a:endParaRPr/>
           </a:p>
         </p:txBody>
       </p:sp>
@@ -7791,7 +7623,7 @@
           <a:noFill/>
         </p:spPr>
         <p:txBody>
-          <a:bodyPr wrap="square" lIns="0" rIns="0" tIns="0" bIns="0">
+          <a:bodyPr wrap="square" lIns="0" tIns="0" rIns="0" bIns="0">
             <a:spAutoFit/>
           </a:bodyPr>
           <a:lstStyle/>
@@ -7833,7 +7665,7 @@
           <a:noFill/>
         </p:spPr>
         <p:txBody>
-          <a:bodyPr wrap="square" lIns="0" rIns="0" tIns="0" bIns="0">
+          <a:bodyPr wrap="square" lIns="0" tIns="0" rIns="0" bIns="0">
             <a:spAutoFit/>
           </a:bodyPr>
           <a:lstStyle/>

</xml_diff>